<commit_message>
deck_blur: rewritten around one-shot vs driven-to-convergence (Dave): plain least squares (3), the gauge's reconstructor one step -- shrinkage, not accuracy (4), the same driven to convergence -- the plain answer with and without calibration, the blur being in the loop's plant (5), the checkerboard on one scale (6), the curves with the iterated line (7); figures as same-scale [true | blurred | reconstructed | error] pairs; 13 slides
Co-Authored-By: Claude Fable 5.1 <noreply@anthropic.com>
</commit_message>
<xml_diff>
--- a/demo_session/deck_blur.pptx
+++ b/demo_session/deck_blur.pptx
@@ -16,6 +16,8 @@
     <p:sldId id="264" r:id="rId15"/>
     <p:sldId id="265" r:id="rId16"/>
     <p:sldId id="266" r:id="rId17"/>
+    <p:sldId id="267" r:id="rId18"/>
+    <p:sldId id="268" r:id="rId19"/>
   </p:sldIdLst>
   <p:sldSz cx="12191695" cy="6858000" type="screen4x3"/>
   <p:notesSz cx="6858000" cy="9144000"/>
@@ -3235,7 +3237,7 @@
                 </a:solidFill>
                 <a:latin typeface="Arial"/>
               </a:rPr>
-              <a:t>The question (Fang Shi, 2026-10-08 talk): the DM is imaged onto the gauge's camera through lenses or off-axis mirrors; how much does the image's blur cost after calibration, and when would it matter?  The answer in one line: blur is a roll-off of the DM's highest spatial frequencies; a calibrated read removes it until the roll-off at the actuator spacing's Nyquist frequency reaches the reconstructor's own floor; the built legs sit two orders of magnitude below that.</a:t>
+              <a:t>The question (Fang Shi, 2026-10-08 talk): the DM is imaged onto the gauge's camera through lenses or off-axis mirrors; how much does the image's blur cost after calibration, and when would it matter?  The answer in one line: blur is a roll-off of the DM's highest spatial frequencies; a one-shot read needs calibration to undo it, and a servo converges to the true surface with or without it until the roll-off at the actuator spacing's Nyquist frequency takes the loop's stability; the built legs sit two orders of magnitude below either limit.</a:t>
             </a:r>
           </a:p>
         </p:txBody>
@@ -3249,6 +3251,568 @@
 </file>
 
 <file path=ppt/slides/slide10.xml><?xml version="1.0" encoding="utf-8"?>
+<p:sld xmlns:a="http://schemas.openxmlformats.org/drawingml/2006/main" xmlns:p="http://schemas.openxmlformats.org/presentationml/2006/main" xmlns:r="http://schemas.openxmlformats.org/officeDocument/2006/relationships">
+  <p:cSld>
+    <p:spTree>
+      <p:nvGrpSpPr>
+        <p:cNvPr id="1" name=""/>
+        <p:cNvGrpSpPr/>
+        <p:nvPr/>
+      </p:nvGrpSpPr>
+      <p:grpSpPr/>
+      <p:sp>
+        <p:nvSpPr>
+          <p:cNvPr id="2" name="TextBox 1"/>
+          <p:cNvSpPr txBox="1"/>
+          <p:nvPr/>
+        </p:nvSpPr>
+        <p:spPr>
+          <a:xfrm>
+            <a:off x="411480" y="201168"/>
+            <a:ext cx="11368735" cy="914400"/>
+          </a:xfrm>
+          <a:prstGeom prst="rect">
+            <a:avLst/>
+          </a:prstGeom>
+          <a:noFill/>
+        </p:spPr>
+        <p:txBody>
+          <a:bodyPr wrap="square">
+            <a:spAutoFit/>
+          </a:bodyPr>
+          <a:lstStyle/>
+          <a:p>
+            <a:pPr>
+              <a:spcAft>
+                <a:spcPts val="400"/>
+              </a:spcAft>
+            </a:pPr>
+            <a:r>
+              <a:rPr sz="2400" b="1">
+                <a:solidFill>
+                  <a:srgbClr val="1F4E79"/>
+                </a:solidFill>
+                <a:latin typeface="Arial"/>
+              </a:rPr>
+              <a:t>What is approximate, and how to run it</a:t>
+            </a:r>
+          </a:p>
+          <a:p>
+            <a:pPr>
+              <a:spcAft>
+                <a:spcPts val="0"/>
+              </a:spcAft>
+            </a:pPr>
+            <a:r>
+              <a:rPr sz="1250" b="0">
+                <a:solidFill>
+                  <a:srgbClr val="6E6E6E"/>
+                </a:solidFill>
+                <a:latin typeface="Arial"/>
+              </a:rPr>
+              <a:t>The demo is a model of the blur alone; its three idealizations are stated, and every number is one command away</a:t>
+            </a:r>
+          </a:p>
+        </p:txBody>
+      </p:sp>
+      <p:sp>
+        <p:nvSpPr>
+          <p:cNvPr id="3" name="Rectangle 2"/>
+          <p:cNvSpPr/>
+          <p:nvPr/>
+        </p:nvSpPr>
+        <p:spPr>
+          <a:xfrm>
+            <a:off x="411480" y="1133856"/>
+            <a:ext cx="11368735" cy="20320"/>
+          </a:xfrm>
+          <a:prstGeom prst="rect">
+            <a:avLst/>
+          </a:prstGeom>
+          <a:solidFill>
+            <a:srgbClr val="B8C6D4"/>
+          </a:solidFill>
+          <a:ln>
+            <a:noFill/>
+          </a:ln>
+          <a:effectLst/>
+        </p:spPr>
+        <p:style>
+          <a:lnRef idx="1">
+            <a:schemeClr val="accent1"/>
+          </a:lnRef>
+          <a:fillRef idx="3">
+            <a:schemeClr val="accent1"/>
+          </a:fillRef>
+          <a:effectRef idx="2">
+            <a:schemeClr val="accent1"/>
+          </a:effectRef>
+          <a:fontRef idx="minor">
+            <a:schemeClr val="lt1"/>
+          </a:fontRef>
+        </p:style>
+        <p:txBody>
+          <a:bodyPr rtlCol="0" anchor="ctr"/>
+          <a:lstStyle/>
+          <a:p>
+            <a:pPr algn="ctr"/>
+          </a:p>
+        </p:txBody>
+      </p:sp>
+      <p:sp>
+        <p:nvSpPr>
+          <p:cNvPr id="4" name="TextBox 3"/>
+          <p:cNvSpPr txBox="1"/>
+          <p:nvPr/>
+        </p:nvSpPr>
+        <p:spPr>
+          <a:xfrm>
+            <a:off x="411480" y="1298448"/>
+            <a:ext cx="5806440" cy="274320"/>
+          </a:xfrm>
+          <a:prstGeom prst="rect">
+            <a:avLst/>
+          </a:prstGeom>
+          <a:noFill/>
+        </p:spPr>
+        <p:txBody>
+          <a:bodyPr wrap="square">
+            <a:spAutoFit/>
+          </a:bodyPr>
+          <a:lstStyle/>
+          <a:p>
+            <a:pPr>
+              <a:spcAft>
+                <a:spcPts val="600"/>
+              </a:spcAft>
+            </a:pPr>
+            <a:r>
+              <a:rPr sz="1200" b="0">
+                <a:solidFill>
+                  <a:srgbClr val="282828"/>
+                </a:solidFill>
+                <a:latin typeface="Arial"/>
+              </a:rPr>
+              <a:t>•  </a:t>
+            </a:r>
+            <a:r>
+              <a:rPr sz="1200" b="1">
+                <a:solidFill>
+                  <a:srgbClr val="282828"/>
+                </a:solidFill>
+                <a:latin typeface="Arial"/>
+              </a:rPr>
+              <a:t>The blur acts on the phase map.</a:t>
+            </a:r>
+            <a:r>
+              <a:rPr sz="1200" b="0">
+                <a:solidFill>
+                  <a:srgbClr val="282828"/>
+                </a:solidFill>
+                <a:latin typeface="Arial"/>
+              </a:rPr>
+              <a:t>  A camera blurs intensity; the four-step phase of blurred fringes equals the blurred phase only near null — true at 0.1 wave (the 30 nm surface), not at a wave.</a:t>
+            </a:r>
+          </a:p>
+          <a:p>
+            <a:pPr>
+              <a:spcAft>
+                <a:spcPts val="600"/>
+              </a:spcAft>
+            </a:pPr>
+            <a:r>
+              <a:rPr sz="1200" b="0">
+                <a:solidFill>
+                  <a:srgbClr val="282828"/>
+                </a:solidFill>
+                <a:latin typeface="Arial"/>
+              </a:rPr>
+              <a:t>•  </a:t>
+            </a:r>
+            <a:r>
+              <a:rPr sz="1200" b="1">
+                <a:solidFill>
+                  <a:srgbClr val="282828"/>
+                </a:solidFill>
+                <a:latin typeface="Arial"/>
+              </a:rPr>
+              <a:t>The built legs are not Gaussians.</a:t>
+            </a:r>
+            <a:r>
+              <a:rPr sz="1200" b="0">
+                <a:solidFill>
+                  <a:srgbClr val="282828"/>
+                </a:solidFill>
+                <a:latin typeface="Arial"/>
+              </a:rPr>
+              <a:t>  The rigorous tool finds a phase gain cos φ with amplitude cross-talk sin φ and a distortion; the Gaussian is matched to it at the actuator-Nyquist transfer only.</a:t>
+            </a:r>
+          </a:p>
+          <a:p>
+            <a:pPr>
+              <a:spcAft>
+                <a:spcPts val="600"/>
+              </a:spcAft>
+            </a:pPr>
+            <a:r>
+              <a:rPr sz="1200" b="0">
+                <a:solidFill>
+                  <a:srgbClr val="282828"/>
+                </a:solidFill>
+                <a:latin typeface="Arial"/>
+              </a:rPr>
+              <a:t>•  </a:t>
+            </a:r>
+            <a:r>
+              <a:rPr sz="1200" b="1">
+                <a:solidFill>
+                  <a:srgbClr val="282828"/>
+                </a:solidFill>
+                <a:latin typeface="Arial"/>
+              </a:rPr>
+              <a:t>The lit set</a:t>
+            </a:r>
+            <a:r>
+              <a:rPr sz="1200" b="0">
+                <a:solidFill>
+                  <a:srgbClr val="282828"/>
+                </a:solidFill>
+                <a:latin typeface="Arial"/>
+              </a:rPr>
+              <a:t> is the demo's 2852 actuators (0.85 × 0.74 of the aperture radius); the benches light 5072 (lens) and 6948 (mirror) from the traced cone.  The error is a per-actuator rms, so the count sets the edge-to-interior ratio, not the scale.</a:t>
+            </a:r>
+          </a:p>
+        </p:txBody>
+      </p:sp>
+      <p:sp>
+        <p:nvSpPr>
+          <p:cNvPr id="5" name="Rectangle 4"/>
+          <p:cNvSpPr/>
+          <p:nvPr/>
+        </p:nvSpPr>
+        <p:spPr>
+          <a:xfrm>
+            <a:off x="6400800" y="1298448"/>
+            <a:ext cx="5394960" cy="1009154"/>
+          </a:xfrm>
+          <a:prstGeom prst="rect">
+            <a:avLst/>
+          </a:prstGeom>
+          <a:solidFill>
+            <a:srgbClr val="FFFFFF"/>
+          </a:solidFill>
+          <a:ln w="9525">
+            <a:solidFill>
+              <a:srgbClr val="1F4E79"/>
+            </a:solidFill>
+          </a:ln>
+          <a:effectLst/>
+        </p:spPr>
+        <p:style>
+          <a:lnRef idx="1">
+            <a:schemeClr val="accent1"/>
+          </a:lnRef>
+          <a:fillRef idx="3">
+            <a:schemeClr val="accent1"/>
+          </a:fillRef>
+          <a:effectRef idx="2">
+            <a:schemeClr val="accent1"/>
+          </a:effectRef>
+          <a:fontRef idx="minor">
+            <a:schemeClr val="lt1"/>
+          </a:fontRef>
+        </p:style>
+        <p:txBody>
+          <a:bodyPr rtlCol="0" anchor="t" wrap="square"/>
+          <a:lstStyle/>
+          <a:p>
+            <a:pPr algn="l">
+              <a:spcAft>
+                <a:spcPts val="100"/>
+              </a:spcAft>
+            </a:pPr>
+            <a:r>
+              <a:rPr sz="1007" b="0">
+                <a:solidFill>
+                  <a:srgbClr val="282828"/>
+                </a:solidFill>
+                <a:latin typeface="Consolas"/>
+              </a:rPr>
+              <a:t>cd &lt;path&gt;/mmacos/templates/40_benches/tg_psi_dm96_oap</a:t>
+            </a:r>
+          </a:p>
+          <a:p>
+            <a:pPr algn="l">
+              <a:spcAft>
+                <a:spcPts val="100"/>
+              </a:spcAft>
+            </a:pPr>
+            <a:r>
+              <a:rPr sz="1007" b="0">
+                <a:solidFill>
+                  <a:srgbClr val="282828"/>
+                </a:solidFill>
+                <a:latin typeface="Consolas"/>
+              </a:rPr>
+              <a:t>matlab</a:t>
+            </a:r>
+          </a:p>
+          <a:p>
+            <a:pPr algn="l">
+              <a:spcAft>
+                <a:spcPts val="100"/>
+              </a:spcAft>
+            </a:pPr>
+            <a:r>
+              <a:rPr sz="1007" b="0">
+                <a:solidFill>
+                  <a:srgbClr val="282828"/>
+                </a:solidFill>
+                <a:latin typeface="Consolas"/>
+              </a:rPr>
+              <a:t>&gt;&gt; pupil_blur_demo                    % ~1 min, no engine</a:t>
+            </a:r>
+          </a:p>
+          <a:p>
+            <a:pPr algn="l">
+              <a:spcAft>
+                <a:spcPts val="100"/>
+              </a:spcAft>
+            </a:pPr>
+            <a:r>
+              <a:rPr sz="1007" b="0">
+                <a:solidFill>
+                  <a:srgbClr val="282828"/>
+                </a:solidFill>
+                <a:latin typeface="Consolas"/>
+              </a:rPr>
+              <a:t>&gt;&gt; pupil_blur_demo('steps_sig', 0.8)  % the steps at another blur</a:t>
+            </a:r>
+          </a:p>
+          <a:p>
+            <a:pPr algn="l">
+              <a:spcAft>
+                <a:spcPts val="100"/>
+              </a:spcAft>
+            </a:pPr>
+            <a:r>
+              <a:rPr sz="1007" b="0">
+                <a:solidFill>
+                  <a:srgbClr val="282828"/>
+                </a:solidFill>
+                <a:latin typeface="Consolas"/>
+              </a:rPr>
+              <a:t>&gt;&gt; pupil_blur_lam_m                   % the weight vs noise (backup)</a:t>
+            </a:r>
+          </a:p>
+        </p:txBody>
+      </p:sp>
+      <p:sp>
+        <p:nvSpPr>
+          <p:cNvPr id="6" name="TextBox 5"/>
+          <p:cNvSpPr txBox="1"/>
+          <p:nvPr/>
+        </p:nvSpPr>
+        <p:spPr>
+          <a:xfrm>
+            <a:off x="6400800" y="2417330"/>
+            <a:ext cx="5394960" cy="274320"/>
+          </a:xfrm>
+          <a:prstGeom prst="rect">
+            <a:avLst/>
+          </a:prstGeom>
+          <a:noFill/>
+        </p:spPr>
+        <p:txBody>
+          <a:bodyPr wrap="square">
+            <a:spAutoFit/>
+          </a:bodyPr>
+          <a:lstStyle/>
+          <a:p>
+            <a:pPr>
+              <a:spcAft>
+                <a:spcPts val="600"/>
+              </a:spcAft>
+            </a:pPr>
+            <a:r>
+              <a:rPr sz="1200" b="0">
+                <a:solidFill>
+                  <a:srgbClr val="282828"/>
+                </a:solidFill>
+                <a:latin typeface="Arial"/>
+              </a:rPr>
+              <a:t>•  </a:t>
+            </a:r>
+            <a:r>
+              <a:rPr sz="1200" b="1">
+                <a:solidFill>
+                  <a:srgbClr val="282828"/>
+                </a:solidFill>
+                <a:latin typeface="Arial"/>
+              </a:rPr>
+              <a:t>Test:</a:t>
+            </a:r>
+            <a:r>
+              <a:rPr sz="1200" b="0">
+                <a:solidFill>
+                  <a:srgbClr val="282828"/>
+                </a:solidFill>
+                <a:latin typeface="Arial"/>
+              </a:rPr>
+              <a:t> ./run_mmacos_tests.sh tPupilBlurDemo (5 assertions, ~7 s; the all-unknowns solve kept as the must-fail control).</a:t>
+            </a:r>
+          </a:p>
+        </p:txBody>
+      </p:sp>
+      <p:sp>
+        <p:nvSpPr>
+          <p:cNvPr id="7" name="TextBox 6"/>
+          <p:cNvSpPr txBox="1"/>
+          <p:nvPr/>
+        </p:nvSpPr>
+        <p:spPr>
+          <a:xfrm>
+            <a:off x="6400800" y="2990354"/>
+            <a:ext cx="5394960" cy="274320"/>
+          </a:xfrm>
+          <a:prstGeom prst="rect">
+            <a:avLst/>
+          </a:prstGeom>
+          <a:noFill/>
+        </p:spPr>
+        <p:txBody>
+          <a:bodyPr wrap="square">
+            <a:spAutoFit/>
+          </a:bodyPr>
+          <a:lstStyle/>
+          <a:p>
+            <a:pPr>
+              <a:spcAft>
+                <a:spcPts val="600"/>
+              </a:spcAft>
+            </a:pPr>
+            <a:r>
+              <a:rPr sz="1050" b="0">
+                <a:solidFill>
+                  <a:srgbClr val="6E6E6E"/>
+                </a:solidFill>
+                <a:latin typeface="Arial"/>
+              </a:rPr>
+              <a:t>Public: nasa-jpl/MACOS_resources, branch dev-candidate.</a:t>
+            </a:r>
+          </a:p>
+        </p:txBody>
+      </p:sp>
+    </p:spTree>
+  </p:cSld>
+  <p:clrMapOvr>
+    <a:masterClrMapping/>
+  </p:clrMapOvr>
+</p:sld>
+</file>
+
+<file path=ppt/slides/slide11.xml><?xml version="1.0" encoding="utf-8"?>
+<p:sld xmlns:a="http://schemas.openxmlformats.org/drawingml/2006/main" xmlns:p="http://schemas.openxmlformats.org/presentationml/2006/main" xmlns:r="http://schemas.openxmlformats.org/officeDocument/2006/relationships">
+  <p:cSld>
+    <p:spTree>
+      <p:nvGrpSpPr>
+        <p:cNvPr id="1" name=""/>
+        <p:cNvGrpSpPr/>
+        <p:nvPr/>
+      </p:nvGrpSpPr>
+      <p:grpSpPr/>
+      <p:sp>
+        <p:nvSpPr>
+          <p:cNvPr id="2" name="TextBox 1"/>
+          <p:cNvSpPr txBox="1"/>
+          <p:nvPr/>
+        </p:nvSpPr>
+        <p:spPr>
+          <a:xfrm>
+            <a:off x="411480" y="201168"/>
+            <a:ext cx="11368735" cy="914400"/>
+          </a:xfrm>
+          <a:prstGeom prst="rect">
+            <a:avLst/>
+          </a:prstGeom>
+          <a:noFill/>
+        </p:spPr>
+        <p:txBody>
+          <a:bodyPr wrap="square">
+            <a:spAutoFit/>
+          </a:bodyPr>
+          <a:lstStyle/>
+          <a:p>
+            <a:pPr>
+              <a:spcAft>
+                <a:spcPts val="400"/>
+              </a:spcAft>
+            </a:pPr>
+            <a:r>
+              <a:rPr sz="2400" b="1">
+                <a:solidFill>
+                  <a:srgbClr val="1F4E79"/>
+                </a:solidFill>
+                <a:latin typeface="Arial"/>
+              </a:rPr>
+              <a:t>Backup</a:t>
+            </a:r>
+          </a:p>
+        </p:txBody>
+      </p:sp>
+      <p:sp>
+        <p:nvSpPr>
+          <p:cNvPr id="3" name="Rectangle 2"/>
+          <p:cNvSpPr/>
+          <p:nvPr/>
+        </p:nvSpPr>
+        <p:spPr>
+          <a:xfrm>
+            <a:off x="411480" y="914400"/>
+            <a:ext cx="11368735" cy="20320"/>
+          </a:xfrm>
+          <a:prstGeom prst="rect">
+            <a:avLst/>
+          </a:prstGeom>
+          <a:solidFill>
+            <a:srgbClr val="B8C6D4"/>
+          </a:solidFill>
+          <a:ln>
+            <a:noFill/>
+          </a:ln>
+          <a:effectLst/>
+        </p:spPr>
+        <p:style>
+          <a:lnRef idx="1">
+            <a:schemeClr val="accent1"/>
+          </a:lnRef>
+          <a:fillRef idx="3">
+            <a:schemeClr val="accent1"/>
+          </a:fillRef>
+          <a:effectRef idx="2">
+            <a:schemeClr val="accent1"/>
+          </a:effectRef>
+          <a:fontRef idx="minor">
+            <a:schemeClr val="lt1"/>
+          </a:fontRef>
+        </p:style>
+        <p:txBody>
+          <a:bodyPr rtlCol="0" anchor="ctr"/>
+          <a:lstStyle/>
+          <a:p>
+            <a:pPr algn="ctr"/>
+          </a:p>
+        </p:txBody>
+      </p:sp>
+    </p:spTree>
+  </p:cSld>
+  <p:clrMapOvr>
+    <a:masterClrMapping/>
+  </p:clrMapOvr>
+</p:sld>
+</file>
+
+<file path=ppt/slides/slide12.xml><?xml version="1.0" encoding="utf-8"?>
 <p:sld xmlns:a="http://schemas.openxmlformats.org/drawingml/2006/main" xmlns:p="http://schemas.openxmlformats.org/presentationml/2006/main" xmlns:r="http://schemas.openxmlformats.org/officeDocument/2006/relationships">
   <p:cSld>
     <p:spTree>
@@ -4101,7 +4665,7 @@
                 </a:solidFill>
                 <a:latin typeface="Arial"/>
               </a:rPr>
-              <a:t>The bias scales with λ_m</a:t>
+              <a:t>The one-step shrinkage scales with λ_m</a:t>
             </a:r>
             <a:r>
               <a:rPr sz="1500" b="0">
@@ -4128,7 +4692,7 @@
                 </a:solidFill>
                 <a:latin typeface="Arial"/>
               </a:rPr>
-              <a:t> at the unregularized least-squares floor, 0.90 pm at 10¹⁴ photons and 2.85 at 10¹³ — the gauge deck's 1.4 / 2.3 pm class.  So the record's 1 % is a regularization choice, not physics.  </a:t>
+              <a:t> at the unregularized least-squares floor, 0.90 pm at 10¹⁴ photons and 2.85 at 10¹³ — the gauge deck's 1.4 / 2.3 pm class.  Driven to convergence the shrinkage is gone (slide 5); it sets how many steps the servo needs, not where it ends.  </a:t>
             </a:r>
             <a:r>
               <a:rPr sz="1500" b="1">
@@ -4159,7 +4723,7 @@
         </p:nvSpPr>
         <p:spPr>
           <a:xfrm>
-            <a:off x="411480" y="4539996"/>
+            <a:off x="411480" y="4787646"/>
             <a:ext cx="11368735" cy="274320"/>
           </a:xfrm>
           <a:prstGeom prst="rect">
@@ -4198,7 +4762,7 @@
 </p:sld>
 </file>
 
-<file path=ppt/slides/slide11.xml><?xml version="1.0" encoding="utf-8"?>
+<file path=ppt/slides/slide13.xml><?xml version="1.0" encoding="utf-8"?>
 <p:sld xmlns:a="http://schemas.openxmlformats.org/drawingml/2006/main" xmlns:p="http://schemas.openxmlformats.org/presentationml/2006/main" xmlns:r="http://schemas.openxmlformats.org/officeDocument/2006/relationships">
   <p:cSld>
     <p:spTree>
@@ -4317,7 +4881,7 @@
         </p:nvGraphicFramePr>
         <p:xfrm>
           <a:off x="411480" y="1298448"/>
-          <a:ext cx="11368735" cy="1680210"/>
+          <a:ext cx="11368735" cy="1960245"/>
         </p:xfrm>
         <a:graphic>
           <a:graphicData uri="http://schemas.openxmlformats.org/drawingml/2006/table">
@@ -4326,8 +4890,8 @@
                 <a:tableStyleId>{5C22544A-7EE6-4342-B048-85BDC9FD1C3A}</a:tableStyleId>
               </a:tblPr>
               <a:tblGrid>
-                <a:gridCol w="509524"/>
-                <a:gridCol w="10859211"/>
+                <a:gridCol w="654812"/>
+                <a:gridCol w="10713923"/>
               </a:tblGrid>
               <a:tr h="280035">
                 <a:tc>
@@ -4388,7 +4952,7 @@
                           </a:solidFill>
                           <a:latin typeface="Arial"/>
                         </a:rPr>
-                        <a:t>3, 4</a:t>
+                        <a:t>3, 4, 5</a:t>
                       </a:r>
                     </a:p>
                   </a:txBody>
@@ -4434,7 +4998,7 @@
                           </a:solidFill>
                           <a:latin typeface="Arial"/>
                         </a:rPr>
-                        <a:t>5</a:t>
+                        <a:t>6</a:t>
                       </a:r>
                     </a:p>
                   </a:txBody>
@@ -4456,7 +5020,7 @@
                           </a:solidFill>
                           <a:latin typeface="Arial"/>
                         </a:rPr>
-                        <a:t>pupil_blur_demo_curve.png; the two sweep tables (regularized and plain) in the report</a:t>
+                        <a:t>pupil_blur_demo_maps.png</a:t>
                       </a:r>
                     </a:p>
                   </a:txBody>
@@ -4480,7 +5044,7 @@
                           </a:solidFill>
                           <a:latin typeface="Arial"/>
                         </a:rPr>
-                        <a:t>6</a:t>
+                        <a:t>7</a:t>
                       </a:r>
                     </a:p>
                   </a:txBody>
@@ -4502,7 +5066,7 @@
                           </a:solidFill>
                           <a:latin typeface="Arial"/>
                         </a:rPr>
-                        <a:t>the report's "built leg on the axis" and "cross-check" sections; runs/pupilsim_redo_lens/, runs/pupilsim_redo_oap/</a:t>
+                        <a:t>pupil_blur_demo_curve.png; the three sweep tables (regularized one step, iterated, plain) in the report</a:t>
                       </a:r>
                     </a:p>
                   </a:txBody>
@@ -4526,7 +5090,7 @@
                           </a:solidFill>
                           <a:latin typeface="Arial"/>
                         </a:rPr>
-                        <a:t>7</a:t>
+                        <a:t>8</a:t>
                       </a:r>
                     </a:p>
                   </a:txBody>
@@ -4548,7 +5112,7 @@
                           </a:solidFill>
                           <a:latin typeface="Arial"/>
                         </a:rPr>
-                        <a:t>the report's "BOX kernel" section</a:t>
+                        <a:t>the report's "built leg on the axis" and "cross-check" sections; runs/pupilsim_redo_lens/, runs/pupilsim_redo_oap/</a:t>
                       </a:r>
                     </a:p>
                   </a:txBody>
@@ -4594,831 +5158,7 @@
                           </a:solidFill>
                           <a:latin typeface="Arial"/>
                         </a:rPr>
-                        <a:t>runs/pupil_blur_demo/pupil_blur_lam_m_report.txt</a:t>
-                      </a:r>
-                    </a:p>
-                  </a:txBody>
-                  <a:tcPr marL="54864" marR="54864" marT="18288" marB="18288">
-                    <a:solidFill>
-                      <a:srgbClr val="FFFFFF"/>
-                    </a:solidFill>
-                  </a:tcPr>
-                </a:tc>
-              </a:tr>
-            </a:tbl>
-          </a:graphicData>
-        </a:graphic>
-      </p:graphicFrame>
-      <p:sp>
-        <p:nvSpPr>
-          <p:cNvPr id="5" name="TextBox 4"/>
-          <p:cNvSpPr txBox="1"/>
-          <p:nvPr/>
-        </p:nvSpPr>
-        <p:spPr>
-          <a:xfrm>
-            <a:off x="411480" y="3124962"/>
-            <a:ext cx="11368735" cy="274320"/>
-          </a:xfrm>
-          <a:prstGeom prst="rect">
-            <a:avLst/>
-          </a:prstGeom>
-          <a:noFill/>
-        </p:spPr>
-        <p:txBody>
-          <a:bodyPr wrap="square">
-            <a:spAutoFit/>
-          </a:bodyPr>
-          <a:lstStyle/>
-          <a:p>
-            <a:pPr>
-              <a:spcAft>
-                <a:spcPts val="600"/>
-              </a:spcAft>
-            </a:pPr>
-            <a:r>
-              <a:rPr sz="1050" b="0">
-                <a:solidFill>
-                  <a:srgbClr val="6E6E6E"/>
-                </a:solidFill>
-                <a:latin typeface="Arial"/>
-              </a:rPr>
-              <a:t>macos/REPORT_pupil_blur.md (TO), macos/NOTE_to_ccmac_pupil_blur_review.md (CC), macos/BRIEF_to_pupil_blur.md; the gauge deck's pupil-imaging slide and REPORT_gauge_ifo.md §6b carry the corrected attribution.</a:t>
-            </a:r>
-          </a:p>
-        </p:txBody>
-      </p:sp>
-    </p:spTree>
-  </p:cSld>
-  <p:clrMapOvr>
-    <a:masterClrMapping/>
-  </p:clrMapOvr>
-</p:sld>
-</file>
-
-<file path=ppt/slides/slide2.xml><?xml version="1.0" encoding="utf-8"?>
-<p:sld xmlns:a="http://schemas.openxmlformats.org/drawingml/2006/main" xmlns:p="http://schemas.openxmlformats.org/presentationml/2006/main" xmlns:r="http://schemas.openxmlformats.org/officeDocument/2006/relationships">
-  <p:cSld>
-    <p:spTree>
-      <p:nvGrpSpPr>
-        <p:cNvPr id="1" name=""/>
-        <p:cNvGrpSpPr/>
-        <p:nvPr/>
-      </p:nvGrpSpPr>
-      <p:grpSpPr/>
-      <p:sp>
-        <p:nvSpPr>
-          <p:cNvPr id="2" name="TextBox 1"/>
-          <p:cNvSpPr txBox="1"/>
-          <p:nvPr/>
-        </p:nvSpPr>
-        <p:spPr>
-          <a:xfrm>
-            <a:off x="411480" y="201168"/>
-            <a:ext cx="11368735" cy="914400"/>
-          </a:xfrm>
-          <a:prstGeom prst="rect">
-            <a:avLst/>
-          </a:prstGeom>
-          <a:noFill/>
-        </p:spPr>
-        <p:txBody>
-          <a:bodyPr wrap="square">
-            <a:spAutoFit/>
-          </a:bodyPr>
-          <a:lstStyle/>
-          <a:p>
-            <a:pPr>
-              <a:spcAft>
-                <a:spcPts val="400"/>
-              </a:spcAft>
-            </a:pPr>
-            <a:r>
-              <a:rPr sz="2400" b="1">
-                <a:solidFill>
-                  <a:srgbClr val="1F4E79"/>
-                </a:solidFill>
-                <a:latin typeface="Arial"/>
-              </a:rPr>
-              <a:t>The question, and how it is answered</a:t>
-            </a:r>
-          </a:p>
-          <a:p>
-            <a:pPr>
-              <a:spcAft>
-                <a:spcPts val="0"/>
-              </a:spcAft>
-            </a:pPr>
-            <a:r>
-              <a:rPr sz="1250" b="0">
-                <a:solidFill>
-                  <a:srgbClr val="6E6E6E"/>
-                </a:solidFill>
-                <a:latin typeface="Arial"/>
-              </a:rPr>
-              <a:t>Four steps anyone can check by eye; the only physics is the DM's influence function and a blur kernel</a:t>
-            </a:r>
-          </a:p>
-        </p:txBody>
-      </p:sp>
-      <p:sp>
-        <p:nvSpPr>
-          <p:cNvPr id="3" name="Rectangle 2"/>
-          <p:cNvSpPr/>
-          <p:nvPr/>
-        </p:nvSpPr>
-        <p:spPr>
-          <a:xfrm>
-            <a:off x="411480" y="1133856"/>
-            <a:ext cx="11368735" cy="20320"/>
-          </a:xfrm>
-          <a:prstGeom prst="rect">
-            <a:avLst/>
-          </a:prstGeom>
-          <a:solidFill>
-            <a:srgbClr val="B8C6D4"/>
-          </a:solidFill>
-          <a:ln>
-            <a:noFill/>
-          </a:ln>
-          <a:effectLst/>
-        </p:spPr>
-        <p:style>
-          <a:lnRef idx="1">
-            <a:schemeClr val="accent1"/>
-          </a:lnRef>
-          <a:fillRef idx="3">
-            <a:schemeClr val="accent1"/>
-          </a:fillRef>
-          <a:effectRef idx="2">
-            <a:schemeClr val="accent1"/>
-          </a:effectRef>
-          <a:fontRef idx="minor">
-            <a:schemeClr val="lt1"/>
-          </a:fontRef>
-        </p:style>
-        <p:txBody>
-          <a:bodyPr rtlCol="0" anchor="ctr"/>
-          <a:lstStyle/>
-          <a:p>
-            <a:pPr algn="ctr"/>
-          </a:p>
-        </p:txBody>
-      </p:sp>
-      <p:sp>
-        <p:nvSpPr>
-          <p:cNvPr id="4" name="TextBox 3"/>
-          <p:cNvSpPr txBox="1"/>
-          <p:nvPr/>
-        </p:nvSpPr>
-        <p:spPr>
-          <a:xfrm>
-            <a:off x="411480" y="1298448"/>
-            <a:ext cx="5806440" cy="274320"/>
-          </a:xfrm>
-          <a:prstGeom prst="rect">
-            <a:avLst/>
-          </a:prstGeom>
-          <a:noFill/>
-        </p:spPr>
-        <p:txBody>
-          <a:bodyPr wrap="square">
-            <a:spAutoFit/>
-          </a:bodyPr>
-          <a:lstStyle/>
-          <a:p>
-            <a:pPr>
-              <a:spcAft>
-                <a:spcPts val="600"/>
-              </a:spcAft>
-            </a:pPr>
-            <a:r>
-              <a:rPr sz="1200" b="0">
-                <a:solidFill>
-                  <a:srgbClr val="282828"/>
-                </a:solidFill>
-                <a:latin typeface="Arial"/>
-              </a:rPr>
-              <a:t>•  </a:t>
-            </a:r>
-            <a:r>
-              <a:rPr sz="1200" b="1">
-                <a:solidFill>
-                  <a:srgbClr val="282828"/>
-                </a:solidFill>
-                <a:latin typeface="Arial"/>
-              </a:rPr>
-              <a:t>1. A known surface.</a:t>
-            </a:r>
-            <a:r>
-              <a:rPr sz="1200" b="0">
-                <a:solidFill>
-                  <a:srgbClr val="282828"/>
-                </a:solidFill>
-                <a:latin typeface="Arial"/>
-              </a:rPr>
-              <a:t>  96 × 96 actuators at 1 mm spacing (the "pitch"); each actuator lifts a Gaussian bump of 0.85 mm 1/e radius; a random 30 nm rms command (the gauge's working surface) and, as the hardest case, a ±50 nm checkerboard — the finest pattern the DM can make.</a:t>
-            </a:r>
-          </a:p>
-          <a:p>
-            <a:pPr>
-              <a:spcAft>
-                <a:spcPts val="600"/>
-              </a:spcAft>
-            </a:pPr>
-            <a:r>
-              <a:rPr sz="1200" b="0">
-                <a:solidFill>
-                  <a:srgbClr val="282828"/>
-                </a:solidFill>
-                <a:latin typeface="Arial"/>
-              </a:rPr>
-              <a:t>•  </a:t>
-            </a:r>
-            <a:r>
-              <a:rPr sz="1200" b="1">
-                <a:solidFill>
-                  <a:srgbClr val="282828"/>
-                </a:solidFill>
-                <a:latin typeface="Arial"/>
-              </a:rPr>
-              <a:t>2. The blur.</a:t>
-            </a:r>
-            <a:r>
-              <a:rPr sz="1200" b="0">
-                <a:solidFill>
-                  <a:srgbClr val="282828"/>
-                </a:solidFill>
-                <a:latin typeface="Arial"/>
-              </a:rPr>
-              <a:t>  The surface is convolved with a Gaussian of 1/e radius σ, swept from 0 to 1.5 pitch, plus 20 pm of read noise per map pixel: this is what the camera sees.  (A detector-cell average — a box — is the second kernel, for a photodiode array.)</a:t>
-            </a:r>
-          </a:p>
-          <a:p>
-            <a:pPr>
-              <a:spcAft>
-                <a:spcPts val="600"/>
-              </a:spcAft>
-            </a:pPr>
-            <a:r>
-              <a:rPr sz="1200" b="0">
-                <a:solidFill>
-                  <a:srgbClr val="282828"/>
-                </a:solidFill>
-                <a:latin typeface="Arial"/>
-              </a:rPr>
-              <a:t>•  </a:t>
-            </a:r>
-            <a:r>
-              <a:rPr sz="1200" b="1">
-                <a:solidFill>
-                  <a:srgbClr val="282828"/>
-                </a:solidFill>
-                <a:latin typeface="Arial"/>
-              </a:rPr>
-              <a:t>3. The reconstruction.</a:t>
-            </a:r>
-            <a:r>
-              <a:rPr sz="1200" b="0">
-                <a:solidFill>
-                  <a:srgbClr val="282828"/>
-                </a:solidFill>
-                <a:latin typeface="Arial"/>
-              </a:rPr>
-              <a:t>  The actuator commands are recovered from the blurred map by least squares against a response matrix (one column per lit actuator), </a:t>
-            </a:r>
-            <a:r>
-              <a:rPr sz="1200" b="1">
-                <a:solidFill>
-                  <a:srgbClr val="282828"/>
-                </a:solidFill>
-                <a:latin typeface="Arial"/>
-              </a:rPr>
-              <a:t>without calibration</a:t>
-            </a:r>
-            <a:r>
-              <a:rPr sz="1200" b="0">
-                <a:solidFill>
-                  <a:srgbClr val="282828"/>
-                </a:solidFill>
-                <a:latin typeface="Arial"/>
-              </a:rPr>
-              <a:t> — the matrix built from the unblurred influence, as if no one knew about the blur — and </a:t>
-            </a:r>
-            <a:r>
-              <a:rPr sz="1200" b="1">
-                <a:solidFill>
-                  <a:srgbClr val="282828"/>
-                </a:solidFill>
-                <a:latin typeface="Arial"/>
-              </a:rPr>
-              <a:t>with calibration</a:t>
-            </a:r>
-            <a:r>
-              <a:rPr sz="1200" b="0">
-                <a:solidFill>
-                  <a:srgbClr val="282828"/>
-                </a:solidFill>
-                <a:latin typeface="Arial"/>
-              </a:rPr>
-              <a:t> — the matrix built from the blurred influence, which is what measuring the response matrix through the camera does automatically.</a:t>
-            </a:r>
-          </a:p>
-          <a:p>
-            <a:pPr>
-              <a:spcAft>
-                <a:spcPts val="600"/>
-              </a:spcAft>
-            </a:pPr>
-            <a:r>
-              <a:rPr sz="1200" b="0">
-                <a:solidFill>
-                  <a:srgbClr val="282828"/>
-                </a:solidFill>
-                <a:latin typeface="Arial"/>
-              </a:rPr>
-              <a:t>•  </a:t>
-            </a:r>
-            <a:r>
-              <a:rPr sz="1200" b="1">
-                <a:solidFill>
-                  <a:srgbClr val="282828"/>
-                </a:solidFill>
-                <a:latin typeface="Arial"/>
-              </a:rPr>
-              <a:t>4. The score.</a:t>
-            </a:r>
-            <a:r>
-              <a:rPr sz="1200" b="0">
-                <a:solidFill>
-                  <a:srgbClr val="282828"/>
-                </a:solidFill>
-                <a:latin typeface="Arial"/>
-              </a:rPr>
-              <a:t>  rms of (recovered − true) commands over the 2852 lit actuators, as a percentage of the command rms; and the reconstructed surface against the true one.</a:t>
-            </a:r>
-          </a:p>
-        </p:txBody>
-      </p:sp>
-      <p:sp>
-        <p:nvSpPr>
-          <p:cNvPr id="5" name="TextBox 4"/>
-          <p:cNvSpPr txBox="1"/>
-          <p:nvPr/>
-        </p:nvSpPr>
-        <p:spPr>
-          <a:xfrm>
-            <a:off x="6400800" y="1298448"/>
-            <a:ext cx="5394960" cy="274320"/>
-          </a:xfrm>
-          <a:prstGeom prst="rect">
-            <a:avLst/>
-          </a:prstGeom>
-          <a:noFill/>
-        </p:spPr>
-        <p:txBody>
-          <a:bodyPr wrap="square">
-            <a:spAutoFit/>
-          </a:bodyPr>
-          <a:lstStyle/>
-          <a:p>
-            <a:pPr>
-              <a:spcAft>
-                <a:spcPts val="600"/>
-              </a:spcAft>
-            </a:pPr>
-            <a:r>
-              <a:rPr sz="1200" b="0">
-                <a:solidFill>
-                  <a:srgbClr val="282828"/>
-                </a:solidFill>
-                <a:latin typeface="Arial"/>
-              </a:rPr>
-              <a:t>•  </a:t>
-            </a:r>
-            <a:r>
-              <a:rPr sz="1200" b="1">
-                <a:solidFill>
-                  <a:srgbClr val="282828"/>
-                </a:solidFill>
-                <a:latin typeface="Arial"/>
-              </a:rPr>
-              <a:t>Two reconstructors.</a:t>
-            </a:r>
-            <a:r>
-              <a:rPr sz="1200" b="0">
-                <a:solidFill>
-                  <a:srgbClr val="282828"/>
-                </a:solidFill>
-                <a:latin typeface="Arial"/>
-              </a:rPr>
-              <a:t>  Plain least squares: the matrix inverted with no regularization to speak of (λ = 10⁻⁹) — the simplest possible estimator.  The gauge's own: the same matrix with the record's Tikhonov weight (λ_m = 10⁻³ of the median column energy, matrix_lam in every bench run) — what every number in the gauge deck used.  The regularization protects the measured matrix against its own noise, at the price of a floor: 1.0 % on the random surface and 6 % on the checkerboard at zero blur, photon-independent.</a:t>
-            </a:r>
-          </a:p>
-          <a:p>
-            <a:pPr>
-              <a:spcAft>
-                <a:spcPts val="600"/>
-              </a:spcAft>
-            </a:pPr>
-            <a:r>
-              <a:rPr sz="1200" b="0">
-                <a:solidFill>
-                  <a:srgbClr val="282828"/>
-                </a:solidFill>
-                <a:latin typeface="Arial"/>
-              </a:rPr>
-              <a:t>•  </a:t>
-            </a:r>
-            <a:r>
-              <a:rPr sz="1200" b="1">
-                <a:solidFill>
-                  <a:srgbClr val="282828"/>
-                </a:solidFill>
-                <a:latin typeface="Arial"/>
-              </a:rPr>
-              <a:t>The built benches on the axis.</a:t>
-            </a:r>
-            <a:r>
-              <a:rPr sz="1200" b="0">
-                <a:solidFill>
-                  <a:srgbClr val="282828"/>
-                </a:solidFill>
-                <a:latin typeface="Arial"/>
-              </a:rPr>
-              <a:t>  The rigorous tool (tg96_pupilsim, engine-traced) gives each leg's transfer at the actuator Nyquist frequency: 0.9999 (lens rig), 0.9994 (mirror rig).  The Gaussian with the same transfer has σ = 0.006 and 0.016 pitch — where they sit on the curves.</a:t>
-            </a:r>
-          </a:p>
-        </p:txBody>
-      </p:sp>
-      <p:sp>
-        <p:nvSpPr>
-          <p:cNvPr id="6" name="TextBox 5"/>
-          <p:cNvSpPr txBox="1"/>
-          <p:nvPr/>
-        </p:nvSpPr>
-        <p:spPr>
-          <a:xfrm>
-            <a:off x="6400800" y="4190999"/>
-            <a:ext cx="5394960" cy="274320"/>
-          </a:xfrm>
-          <a:prstGeom prst="rect">
-            <a:avLst/>
-          </a:prstGeom>
-          <a:noFill/>
-        </p:spPr>
-        <p:txBody>
-          <a:bodyPr wrap="square">
-            <a:spAutoFit/>
-          </a:bodyPr>
-          <a:lstStyle/>
-          <a:p>
-            <a:pPr>
-              <a:spcAft>
-                <a:spcPts val="600"/>
-              </a:spcAft>
-            </a:pPr>
-            <a:r>
-              <a:rPr sz="1050" b="0">
-                <a:solidFill>
-                  <a:srgbClr val="6E6E6E"/>
-                </a:solidFill>
-                <a:latin typeface="Arial"/>
-              </a:rPr>
-              <a:t>pupil_blur_demo.m (templates/40_benches/tg_psi_dm96_oap/), ~1 min, no engine; record runs/pupil_blur_demo/pupil_blur_demo_report.txt.  Approximations: the blur acts on the phase map (the small-phase limit, 0.1 wave here); the legs are matched to a Gaussian at the Nyquist transfer only.</a:t>
-            </a:r>
-          </a:p>
-        </p:txBody>
-      </p:sp>
-    </p:spTree>
-  </p:cSld>
-  <p:clrMapOvr>
-    <a:masterClrMapping/>
-  </p:clrMapOvr>
-</p:sld>
-</file>
-
-<file path=ppt/slides/slide3.xml><?xml version="1.0" encoding="utf-8"?>
-<p:sld xmlns:a="http://schemas.openxmlformats.org/drawingml/2006/main" xmlns:p="http://schemas.openxmlformats.org/presentationml/2006/main" xmlns:r="http://schemas.openxmlformats.org/officeDocument/2006/relationships">
-  <p:cSld>
-    <p:spTree>
-      <p:nvGrpSpPr>
-        <p:cNvPr id="1" name=""/>
-        <p:cNvGrpSpPr/>
-        <p:nvPr/>
-      </p:nvGrpSpPr>
-      <p:grpSpPr/>
-      <p:sp>
-        <p:nvSpPr>
-          <p:cNvPr id="2" name="TextBox 1"/>
-          <p:cNvSpPr txBox="1"/>
-          <p:nvPr/>
-        </p:nvSpPr>
-        <p:spPr>
-          <a:xfrm>
-            <a:off x="411480" y="201168"/>
-            <a:ext cx="11368735" cy="914400"/>
-          </a:xfrm>
-          <a:prstGeom prst="rect">
-            <a:avLst/>
-          </a:prstGeom>
-          <a:noFill/>
-        </p:spPr>
-        <p:txBody>
-          <a:bodyPr wrap="square">
-            <a:spAutoFit/>
-          </a:bodyPr>
-          <a:lstStyle/>
-          <a:p>
-            <a:pPr>
-              <a:spcAft>
-                <a:spcPts val="400"/>
-              </a:spcAft>
-            </a:pPr>
-            <a:r>
-              <a:rPr sz="2400" b="1">
-                <a:solidFill>
-                  <a:srgbClr val="1F4E79"/>
-                </a:solidFill>
-                <a:latin typeface="Arial"/>
-              </a:rPr>
-              <a:t>Step by step, plain least squares</a:t>
-            </a:r>
-          </a:p>
-          <a:p>
-            <a:pPr>
-              <a:spcAft>
-                <a:spcPts val="0"/>
-              </a:spcAft>
-            </a:pPr>
-            <a:r>
-              <a:rPr sz="1250" b="0">
-                <a:solidFill>
-                  <a:srgbClr val="6E6E6E"/>
-                </a:solidFill>
-                <a:latin typeface="Arial"/>
-              </a:rPr>
-              <a:t>The 30 nm working surface, blurred at σ = 0.5 pitch (54 % transfer at the actuator Nyquist): the uncalibrated read returns the blurred surface; the calibrated read returns the true one</a:t>
-            </a:r>
-          </a:p>
-        </p:txBody>
-      </p:sp>
-      <p:sp>
-        <p:nvSpPr>
-          <p:cNvPr id="3" name="Rectangle 2"/>
-          <p:cNvSpPr/>
-          <p:nvPr/>
-        </p:nvSpPr>
-        <p:spPr>
-          <a:xfrm>
-            <a:off x="411480" y="1133856"/>
-            <a:ext cx="11368735" cy="20320"/>
-          </a:xfrm>
-          <a:prstGeom prst="rect">
-            <a:avLst/>
-          </a:prstGeom>
-          <a:solidFill>
-            <a:srgbClr val="B8C6D4"/>
-          </a:solidFill>
-          <a:ln>
-            <a:noFill/>
-          </a:ln>
-          <a:effectLst/>
-        </p:spPr>
-        <p:style>
-          <a:lnRef idx="1">
-            <a:schemeClr val="accent1"/>
-          </a:lnRef>
-          <a:fillRef idx="3">
-            <a:schemeClr val="accent1"/>
-          </a:fillRef>
-          <a:effectRef idx="2">
-            <a:schemeClr val="accent1"/>
-          </a:effectRef>
-          <a:fontRef idx="minor">
-            <a:schemeClr val="lt1"/>
-          </a:fontRef>
-        </p:style>
-        <p:txBody>
-          <a:bodyPr rtlCol="0" anchor="ctr"/>
-          <a:lstStyle/>
-          <a:p>
-            <a:pPr algn="ctr"/>
-          </a:p>
-        </p:txBody>
-      </p:sp>
-      <p:pic>
-        <p:nvPicPr>
-          <p:cNvPr id="4" name="Picture 3" descr="blur_steps_lsq.png"/>
-          <p:cNvPicPr>
-            <a:picLocks noChangeAspect="1"/>
-          </p:cNvPicPr>
-          <p:nvPr/>
-        </p:nvPicPr>
-        <p:blipFill>
-          <a:blip r:embed="rId2"/>
-          <a:stretch>
-            <a:fillRect/>
-          </a:stretch>
-        </p:blipFill>
-        <p:spPr>
-          <a:xfrm>
-            <a:off x="411480" y="1298448"/>
-            <a:ext cx="11368735" cy="2191778"/>
-          </a:xfrm>
-          <a:prstGeom prst="rect">
-            <a:avLst/>
-          </a:prstGeom>
-        </p:spPr>
-      </p:pic>
-      <p:sp>
-        <p:nvSpPr>
-          <p:cNvPr id="5" name="TextBox 4"/>
-          <p:cNvSpPr txBox="1"/>
-          <p:nvPr/>
-        </p:nvSpPr>
-        <p:spPr>
-          <a:xfrm>
-            <a:off x="411480" y="3508514"/>
-            <a:ext cx="11368735" cy="394208"/>
-          </a:xfrm>
-          <a:prstGeom prst="rect">
-            <a:avLst/>
-          </a:prstGeom>
-          <a:noFill/>
-        </p:spPr>
-        <p:txBody>
-          <a:bodyPr wrap="square">
-            <a:spAutoFit/>
-          </a:bodyPr>
-          <a:lstStyle/>
-          <a:p>
-            <a:pPr algn="ctr">
-              <a:spcAft>
-                <a:spcPts val="0"/>
-              </a:spcAft>
-            </a:pPr>
-            <a:r>
-              <a:rPr sz="1000" b="0">
-                <a:solidFill>
-                  <a:srgbClr val="6E6E6E"/>
-                </a:solidFill>
-                <a:latin typeface="Arial"/>
-              </a:rPr>
-              <a:t>Left to right: the true surface; the blurred surface the camera sees; the surface rebuilt from the commands recovered WITHOUT calibration; the same WITH calibration.  Center 24 × 24 pitches of the 96 × 96 DM, same gray scale (±110 nm).</a:t>
-            </a:r>
-          </a:p>
-        </p:txBody>
-      </p:sp>
-      <p:graphicFrame>
-        <p:nvGraphicFramePr>
-          <p:cNvPr id="6" name="Table 5"/>
-          <p:cNvGraphicFramePr>
-            <a:graphicFrameLocks noGrp="1"/>
-          </p:cNvGraphicFramePr>
-          <p:nvPr/>
-        </p:nvGraphicFramePr>
-        <p:xfrm>
-          <a:off x="411480" y="3939298"/>
-          <a:ext cx="11368734" cy="840105"/>
-        </p:xfrm>
-        <a:graphic>
-          <a:graphicData uri="http://schemas.openxmlformats.org/drawingml/2006/table">
-            <a:tbl>
-              <a:tblPr firstRow="1" bandRow="1">
-                <a:tableStyleId>{5C22544A-7EE6-4342-B048-85BDC9FD1C3A}</a:tableStyleId>
-              </a:tblPr>
-              <a:tblGrid>
-                <a:gridCol w="3083417"/>
-                <a:gridCol w="1090676"/>
-                <a:gridCol w="7194641"/>
-              </a:tblGrid>
-              <a:tr h="280035">
-                <a:tc>
-                  <a:txBody>
-                    <a:bodyPr wrap="square"/>
-                    <a:lstStyle/>
-                    <a:p>
-                      <a:r>
-                        <a:rPr sz="1100" b="1">
-                          <a:solidFill>
-                            <a:srgbClr val="FFFFFF"/>
-                          </a:solidFill>
-                          <a:latin typeface="Arial"/>
-                        </a:rPr>
-                        <a:t>plain least squares at σ = 0.5 pitch</a:t>
-                      </a:r>
-                    </a:p>
-                  </a:txBody>
-                  <a:tcPr marL="54864" marR="54864" marT="18288" marB="18288">
-                    <a:solidFill>
-                      <a:srgbClr val="1F4E79"/>
-                    </a:solidFill>
-                  </a:tcPr>
-                </a:tc>
-                <a:tc>
-                  <a:txBody>
-                    <a:bodyPr wrap="square"/>
-                    <a:lstStyle/>
-                    <a:p>
-                      <a:r>
-                        <a:rPr sz="1100" b="1">
-                          <a:solidFill>
-                            <a:srgbClr val="FFFFFF"/>
-                          </a:solidFill>
-                          <a:latin typeface="Arial"/>
-                        </a:rPr>
-                        <a:t>command error</a:t>
-                      </a:r>
-                    </a:p>
-                  </a:txBody>
-                  <a:tcPr marL="54864" marR="54864" marT="18288" marB="18288">
-                    <a:solidFill>
-                      <a:srgbClr val="1F4E79"/>
-                    </a:solidFill>
-                  </a:tcPr>
-                </a:tc>
-                <a:tc>
-                  <a:txBody>
-                    <a:bodyPr wrap="square"/>
-                    <a:lstStyle/>
-                    <a:p>
-                      <a:r>
-                        <a:rPr sz="1100" b="1">
-                          <a:solidFill>
-                            <a:srgbClr val="FFFFFF"/>
-                          </a:solidFill>
-                          <a:latin typeface="Arial"/>
-                        </a:rPr>
-                        <a:t>reconstructed surface vs true</a:t>
-                      </a:r>
-                    </a:p>
-                  </a:txBody>
-                  <a:tcPr marL="54864" marR="54864" marT="18288" marB="18288">
-                    <a:solidFill>
-                      <a:srgbClr val="1F4E79"/>
-                    </a:solidFill>
-                  </a:tcPr>
-                </a:tc>
-              </a:tr>
-              <a:tr h="280035">
-                <a:tc>
-                  <a:txBody>
-                    <a:bodyPr wrap="square"/>
-                    <a:lstStyle/>
-                    <a:p>
-                      <a:r>
-                        <a:rPr sz="1100" b="0">
-                          <a:solidFill>
-                            <a:srgbClr val="282828"/>
-                          </a:solidFill>
-                          <a:latin typeface="Arial"/>
-                        </a:rPr>
-                        <a:t>without calibration</a:t>
-                      </a:r>
-                    </a:p>
-                  </a:txBody>
-                  <a:tcPr marL="54864" marR="54864" marT="18288" marB="18288">
-                    <a:solidFill>
-                      <a:srgbClr val="FFFFFF"/>
-                    </a:solidFill>
-                  </a:tcPr>
-                </a:tc>
-                <a:tc>
-                  <a:txBody>
-                    <a:bodyPr wrap="square"/>
-                    <a:lstStyle/>
-                    <a:p>
-                      <a:r>
-                        <a:rPr sz="1100" b="0">
-                          <a:solidFill>
-                            <a:srgbClr val="282828"/>
-                          </a:solidFill>
-                          <a:latin typeface="Arial"/>
-                        </a:rPr>
-                        <a:t>37 %</a:t>
-                      </a:r>
-                    </a:p>
-                  </a:txBody>
-                  <a:tcPr marL="54864" marR="54864" marT="18288" marB="18288">
-                    <a:solidFill>
-                      <a:srgbClr val="FFFFFF"/>
-                    </a:solidFill>
-                  </a:tcPr>
-                </a:tc>
-                <a:tc>
-                  <a:txBody>
-                    <a:bodyPr wrap="square"/>
-                    <a:lstStyle/>
-                    <a:p>
-                      <a:r>
-                        <a:rPr sz="1100" b="0">
-                          <a:solidFill>
-                            <a:srgbClr val="282828"/>
-                          </a:solidFill>
-                          <a:latin typeface="Arial"/>
-                        </a:rPr>
-                        <a:t>5.1 nm rms — the blurred surface itself (it differs from the true one by 5.2 nm rms)</a:t>
+                        <a:t>the report's "BOX kernel" section</a:t>
                       </a:r>
                     </a:p>
                   </a:txBody>
@@ -5442,7 +5182,7 @@
                           </a:solidFill>
                           <a:latin typeface="Arial"/>
                         </a:rPr>
-                        <a:t>with calibration</a:t>
+                        <a:t>11</a:t>
                       </a:r>
                     </a:p>
                   </a:txBody>
@@ -5464,29 +5204,7 @@
                           </a:solidFill>
                           <a:latin typeface="Arial"/>
                         </a:rPr>
-                        <a:t>0.09 %</a:t>
-                      </a:r>
-                    </a:p>
-                  </a:txBody>
-                  <a:tcPr marL="54864" marR="54864" marT="18288" marB="18288">
-                    <a:solidFill>
-                      <a:srgbClr val="ECF1F6"/>
-                    </a:solidFill>
-                  </a:tcPr>
-                </a:tc>
-                <a:tc>
-                  <a:txBody>
-                    <a:bodyPr wrap="square"/>
-                    <a:lstStyle/>
-                    <a:p>
-                      <a:r>
-                        <a:rPr sz="1100" b="0">
-                          <a:solidFill>
-                            <a:srgbClr val="282828"/>
-                          </a:solidFill>
-                          <a:latin typeface="Arial"/>
-                        </a:rPr>
-                        <a:t>0.007 nm rms</a:t>
+                        <a:t>runs/pupil_blur_demo/pupil_blur_lam_m_report.txt</a:t>
                       </a:r>
                     </a:p>
                   </a:txBody>
@@ -5503,13 +5221,13 @@
       </p:graphicFrame>
       <p:sp>
         <p:nvSpPr>
-          <p:cNvPr id="7" name="TextBox 6"/>
+          <p:cNvPr id="5" name="TextBox 4"/>
           <p:cNvSpPr txBox="1"/>
           <p:nvPr/>
         </p:nvSpPr>
         <p:spPr>
           <a:xfrm>
-            <a:off x="411480" y="4925707"/>
+            <a:off x="411480" y="3404997"/>
             <a:ext cx="11368735" cy="274320"/>
           </a:xfrm>
           <a:prstGeom prst="rect">
@@ -5529,63 +5247,144 @@
               </a:spcAft>
             </a:pPr>
             <a:r>
-              <a:rPr sz="1500" b="0">
-                <a:solidFill>
-                  <a:srgbClr val="282828"/>
-                </a:solidFill>
-                <a:latin typeface="Arial"/>
-              </a:rPr>
-              <a:t>•  </a:t>
-            </a:r>
-            <a:r>
-              <a:rPr sz="1500" b="1">
-                <a:solidFill>
-                  <a:srgbClr val="282828"/>
-                </a:solidFill>
-                <a:latin typeface="Arial"/>
-              </a:rPr>
-              <a:t>Without calibration the read is faithful to the wrong thing:</a:t>
-            </a:r>
-            <a:r>
-              <a:rPr sz="1500" b="0">
-                <a:solidFill>
-                  <a:srgbClr val="282828"/>
-                </a:solidFill>
-                <a:latin typeface="Arial"/>
-              </a:rPr>
-              <a:t> it reproduces the blurred surface, so every feature is softened and the command error is a third of the command.  </a:t>
-            </a:r>
-            <a:r>
-              <a:rPr sz="1500" b="1">
-                <a:solidFill>
-                  <a:srgbClr val="282828"/>
-                </a:solidFill>
-                <a:latin typeface="Arial"/>
-              </a:rPr>
-              <a:t>With calibration</a:t>
-            </a:r>
-            <a:r>
-              <a:rPr sz="1500" b="0">
-                <a:solidFill>
-                  <a:srgbClr val="282828"/>
-                </a:solidFill>
-                <a:latin typeface="Arial"/>
-              </a:rPr>
-              <a:t> the blur is in the forward model and the inversion undoes it: the true surface to 7 pm, with the 20 pm read noise as the only residual.</a:t>
-            </a:r>
-          </a:p>
-        </p:txBody>
-      </p:sp>
-      <p:sp>
-        <p:nvSpPr>
-          <p:cNvPr id="8" name="TextBox 7"/>
+              <a:rPr sz="1050" b="0">
+                <a:solidFill>
+                  <a:srgbClr val="6E6E6E"/>
+                </a:solidFill>
+                <a:latin typeface="Arial"/>
+              </a:rPr>
+              <a:t>macos/REPORT_pupil_blur.md (TO), macos/NOTE_to_ccmac_pupil_blur_review.md (CC), macos/BRIEF_to_pupil_blur.md; the gauge deck's pupil-imaging slide and REPORT_gauge_ifo.md §6b carry the corrected attribution.</a:t>
+            </a:r>
+          </a:p>
+        </p:txBody>
+      </p:sp>
+    </p:spTree>
+  </p:cSld>
+  <p:clrMapOvr>
+    <a:masterClrMapping/>
+  </p:clrMapOvr>
+</p:sld>
+</file>
+
+<file path=ppt/slides/slide2.xml><?xml version="1.0" encoding="utf-8"?>
+<p:sld xmlns:a="http://schemas.openxmlformats.org/drawingml/2006/main" xmlns:p="http://schemas.openxmlformats.org/presentationml/2006/main" xmlns:r="http://schemas.openxmlformats.org/officeDocument/2006/relationships">
+  <p:cSld>
+    <p:spTree>
+      <p:nvGrpSpPr>
+        <p:cNvPr id="1" name=""/>
+        <p:cNvGrpSpPr/>
+        <p:nvPr/>
+      </p:nvGrpSpPr>
+      <p:grpSpPr/>
+      <p:sp>
+        <p:nvSpPr>
+          <p:cNvPr id="2" name="TextBox 1"/>
           <p:cNvSpPr txBox="1"/>
           <p:nvPr/>
         </p:nvSpPr>
         <p:spPr>
           <a:xfrm>
-            <a:off x="411480" y="5845441"/>
-            <a:ext cx="11368735" cy="274320"/>
+            <a:off x="411480" y="201168"/>
+            <a:ext cx="11368735" cy="914400"/>
+          </a:xfrm>
+          <a:prstGeom prst="rect">
+            <a:avLst/>
+          </a:prstGeom>
+          <a:noFill/>
+        </p:spPr>
+        <p:txBody>
+          <a:bodyPr wrap="square">
+            <a:spAutoFit/>
+          </a:bodyPr>
+          <a:lstStyle/>
+          <a:p>
+            <a:pPr>
+              <a:spcAft>
+                <a:spcPts val="400"/>
+              </a:spcAft>
+            </a:pPr>
+            <a:r>
+              <a:rPr sz="2400" b="1">
+                <a:solidFill>
+                  <a:srgbClr val="1F4E79"/>
+                </a:solidFill>
+                <a:latin typeface="Arial"/>
+              </a:rPr>
+              <a:t>The question, and how it is answered</a:t>
+            </a:r>
+          </a:p>
+          <a:p>
+            <a:pPr>
+              <a:spcAft>
+                <a:spcPts val="0"/>
+              </a:spcAft>
+            </a:pPr>
+            <a:r>
+              <a:rPr sz="1250" b="0">
+                <a:solidFill>
+                  <a:srgbClr val="6E6E6E"/>
+                </a:solidFill>
+                <a:latin typeface="Arial"/>
+              </a:rPr>
+              <a:t>Four steps anyone can check by eye; the only physics is the DM's influence function and a blur kernel</a:t>
+            </a:r>
+          </a:p>
+        </p:txBody>
+      </p:sp>
+      <p:sp>
+        <p:nvSpPr>
+          <p:cNvPr id="3" name="Rectangle 2"/>
+          <p:cNvSpPr/>
+          <p:nvPr/>
+        </p:nvSpPr>
+        <p:spPr>
+          <a:xfrm>
+            <a:off x="411480" y="1133856"/>
+            <a:ext cx="11368735" cy="20320"/>
+          </a:xfrm>
+          <a:prstGeom prst="rect">
+            <a:avLst/>
+          </a:prstGeom>
+          <a:solidFill>
+            <a:srgbClr val="B8C6D4"/>
+          </a:solidFill>
+          <a:ln>
+            <a:noFill/>
+          </a:ln>
+          <a:effectLst/>
+        </p:spPr>
+        <p:style>
+          <a:lnRef idx="1">
+            <a:schemeClr val="accent1"/>
+          </a:lnRef>
+          <a:fillRef idx="3">
+            <a:schemeClr val="accent1"/>
+          </a:fillRef>
+          <a:effectRef idx="2">
+            <a:schemeClr val="accent1"/>
+          </a:effectRef>
+          <a:fontRef idx="minor">
+            <a:schemeClr val="lt1"/>
+          </a:fontRef>
+        </p:style>
+        <p:txBody>
+          <a:bodyPr rtlCol="0" anchor="ctr"/>
+          <a:lstStyle/>
+          <a:p>
+            <a:pPr algn="ctr"/>
+          </a:p>
+        </p:txBody>
+      </p:sp>
+      <p:sp>
+        <p:nvSpPr>
+          <p:cNvPr id="4" name="TextBox 3"/>
+          <p:cNvSpPr txBox="1"/>
+          <p:nvPr/>
+        </p:nvSpPr>
+        <p:spPr>
+          <a:xfrm>
+            <a:off x="411480" y="1298448"/>
+            <a:ext cx="5806440" cy="274320"/>
           </a:xfrm>
           <a:prstGeom prst="rect">
             <a:avLst/>
@@ -5604,13 +5403,629 @@
               </a:spcAft>
             </a:pPr>
             <a:r>
+              <a:rPr sz="1200" b="0">
+                <a:solidFill>
+                  <a:srgbClr val="282828"/>
+                </a:solidFill>
+                <a:latin typeface="Arial"/>
+              </a:rPr>
+              <a:t>•  </a:t>
+            </a:r>
+            <a:r>
+              <a:rPr sz="1200" b="1">
+                <a:solidFill>
+                  <a:srgbClr val="282828"/>
+                </a:solidFill>
+                <a:latin typeface="Arial"/>
+              </a:rPr>
+              <a:t>1. A known surface.</a:t>
+            </a:r>
+            <a:r>
+              <a:rPr sz="1200" b="0">
+                <a:solidFill>
+                  <a:srgbClr val="282828"/>
+                </a:solidFill>
+                <a:latin typeface="Arial"/>
+              </a:rPr>
+              <a:t>  96 × 96 actuators at 1 mm spacing (the "pitch"); each actuator lifts a Gaussian bump of 0.85 mm 1/e radius; a random 30 nm rms command (the gauge's working surface) and, as the hardest case, a ±50 nm checkerboard — the finest pattern the DM can make.</a:t>
+            </a:r>
+          </a:p>
+          <a:p>
+            <a:pPr>
+              <a:spcAft>
+                <a:spcPts val="600"/>
+              </a:spcAft>
+            </a:pPr>
+            <a:r>
+              <a:rPr sz="1200" b="0">
+                <a:solidFill>
+                  <a:srgbClr val="282828"/>
+                </a:solidFill>
+                <a:latin typeface="Arial"/>
+              </a:rPr>
+              <a:t>•  </a:t>
+            </a:r>
+            <a:r>
+              <a:rPr sz="1200" b="1">
+                <a:solidFill>
+                  <a:srgbClr val="282828"/>
+                </a:solidFill>
+                <a:latin typeface="Arial"/>
+              </a:rPr>
+              <a:t>2. The blur.</a:t>
+            </a:r>
+            <a:r>
+              <a:rPr sz="1200" b="0">
+                <a:solidFill>
+                  <a:srgbClr val="282828"/>
+                </a:solidFill>
+                <a:latin typeface="Arial"/>
+              </a:rPr>
+              <a:t>  The surface is convolved with a Gaussian of 1/e radius σ, swept from 0 to 1.5 pitch, plus 20 pm of read noise per map pixel: this is what the camera sees.  (A detector-cell average — a box — is the second kernel, for a photodiode array.)</a:t>
+            </a:r>
+          </a:p>
+          <a:p>
+            <a:pPr>
+              <a:spcAft>
+                <a:spcPts val="600"/>
+              </a:spcAft>
+            </a:pPr>
+            <a:r>
+              <a:rPr sz="1200" b="0">
+                <a:solidFill>
+                  <a:srgbClr val="282828"/>
+                </a:solidFill>
+                <a:latin typeface="Arial"/>
+              </a:rPr>
+              <a:t>•  </a:t>
+            </a:r>
+            <a:r>
+              <a:rPr sz="1200" b="1">
+                <a:solidFill>
+                  <a:srgbClr val="282828"/>
+                </a:solidFill>
+                <a:latin typeface="Arial"/>
+              </a:rPr>
+              <a:t>3. The reconstruction.</a:t>
+            </a:r>
+            <a:r>
+              <a:rPr sz="1200" b="0">
+                <a:solidFill>
+                  <a:srgbClr val="282828"/>
+                </a:solidFill>
+                <a:latin typeface="Arial"/>
+              </a:rPr>
+              <a:t>  The actuator commands are recovered from the blurred map by least squares against a response matrix (one column per lit actuator), </a:t>
+            </a:r>
+            <a:r>
+              <a:rPr sz="1200" b="1">
+                <a:solidFill>
+                  <a:srgbClr val="282828"/>
+                </a:solidFill>
+                <a:latin typeface="Arial"/>
+              </a:rPr>
+              <a:t>without calibration</a:t>
+            </a:r>
+            <a:r>
+              <a:rPr sz="1200" b="0">
+                <a:solidFill>
+                  <a:srgbClr val="282828"/>
+                </a:solidFill>
+                <a:latin typeface="Arial"/>
+              </a:rPr>
+              <a:t> — the matrix built from the unblurred influence, as if no one knew about the blur — and </a:t>
+            </a:r>
+            <a:r>
+              <a:rPr sz="1200" b="1">
+                <a:solidFill>
+                  <a:srgbClr val="282828"/>
+                </a:solidFill>
+                <a:latin typeface="Arial"/>
+              </a:rPr>
+              <a:t>with calibration</a:t>
+            </a:r>
+            <a:r>
+              <a:rPr sz="1200" b="0">
+                <a:solidFill>
+                  <a:srgbClr val="282828"/>
+                </a:solidFill>
+                <a:latin typeface="Arial"/>
+              </a:rPr>
+              <a:t> — the matrix built from the blurred influence, which is what measuring the response matrix through the camera does automatically.</a:t>
+            </a:r>
+          </a:p>
+          <a:p>
+            <a:pPr>
+              <a:spcAft>
+                <a:spcPts val="600"/>
+              </a:spcAft>
+            </a:pPr>
+            <a:r>
+              <a:rPr sz="1200" b="0">
+                <a:solidFill>
+                  <a:srgbClr val="282828"/>
+                </a:solidFill>
+                <a:latin typeface="Arial"/>
+              </a:rPr>
+              <a:t>•  </a:t>
+            </a:r>
+            <a:r>
+              <a:rPr sz="1200" b="1">
+                <a:solidFill>
+                  <a:srgbClr val="282828"/>
+                </a:solidFill>
+                <a:latin typeface="Arial"/>
+              </a:rPr>
+              <a:t>4. The score.</a:t>
+            </a:r>
+            <a:r>
+              <a:rPr sz="1200" b="0">
+                <a:solidFill>
+                  <a:srgbClr val="282828"/>
+                </a:solidFill>
+                <a:latin typeface="Arial"/>
+              </a:rPr>
+              <a:t>  rms of (recovered − true) commands over the 2852 lit actuators, as a percentage of the command rms; and the reconstructed surface against the true one.</a:t>
+            </a:r>
+          </a:p>
+        </p:txBody>
+      </p:sp>
+      <p:sp>
+        <p:nvSpPr>
+          <p:cNvPr id="5" name="TextBox 4"/>
+          <p:cNvSpPr txBox="1"/>
+          <p:nvPr/>
+        </p:nvSpPr>
+        <p:spPr>
+          <a:xfrm>
+            <a:off x="6400800" y="1298448"/>
+            <a:ext cx="5394960" cy="274320"/>
+          </a:xfrm>
+          <a:prstGeom prst="rect">
+            <a:avLst/>
+          </a:prstGeom>
+          <a:noFill/>
+        </p:spPr>
+        <p:txBody>
+          <a:bodyPr wrap="square">
+            <a:spAutoFit/>
+          </a:bodyPr>
+          <a:lstStyle/>
+          <a:p>
+            <a:pPr>
+              <a:spcAft>
+                <a:spcPts val="600"/>
+              </a:spcAft>
+            </a:pPr>
+            <a:r>
+              <a:rPr sz="1200" b="0">
+                <a:solidFill>
+                  <a:srgbClr val="282828"/>
+                </a:solidFill>
+                <a:latin typeface="Arial"/>
+              </a:rPr>
+              <a:t>•  </a:t>
+            </a:r>
+            <a:r>
+              <a:rPr sz="1200" b="1">
+                <a:solidFill>
+                  <a:srgbClr val="282828"/>
+                </a:solidFill>
+                <a:latin typeface="Arial"/>
+              </a:rPr>
+              <a:t>Two reconstructors, and two ways to use them.</a:t>
+            </a:r>
+            <a:r>
+              <a:rPr sz="1200" b="0">
+                <a:solidFill>
+                  <a:srgbClr val="282828"/>
+                </a:solidFill>
+                <a:latin typeface="Arial"/>
+              </a:rPr>
+              <a:t>  Plain least squares: the matrix inverted with no regularization to speak of (λ = 10⁻⁹) — the simplest estimator, and the indicator of where any estimator converges.  The gauge's own: the same matrix with the record's Tikhonov weight (λ_m = 10⁻³ of the median column energy), which protects the measured matrix against its own noise at the price of shrinking a single estimate (1 % on this surface at zero blur).  Each is shown </a:t>
+            </a:r>
+            <a:r>
+              <a:rPr sz="1200" b="1">
+                <a:solidFill>
+                  <a:srgbClr val="282828"/>
+                </a:solidFill>
+                <a:latin typeface="Arial"/>
+              </a:rPr>
+              <a:t>one shot</a:t>
+            </a:r>
+            <a:r>
+              <a:rPr sz="1200" b="0">
+                <a:solidFill>
+                  <a:srgbClr val="282828"/>
+                </a:solidFill>
+                <a:latin typeface="Arial"/>
+              </a:rPr>
+              <a:t> (a capture, an absolute read) and </a:t>
+            </a:r>
+            <a:r>
+              <a:rPr sz="1200" b="1">
+                <a:solidFill>
+                  <a:srgbClr val="282828"/>
+                </a:solidFill>
+                <a:latin typeface="Arial"/>
+              </a:rPr>
+              <a:t>driven to convergence</a:t>
+            </a:r>
+            <a:r>
+              <a:rPr sz="1200" b="0">
+                <a:solidFill>
+                  <a:srgbClr val="282828"/>
+                </a:solidFill>
+                <a:latin typeface="Arial"/>
+              </a:rPr>
+              <a:t> as the gauge's servo uses it: read the residual, correct, read again.</a:t>
+            </a:r>
+          </a:p>
+          <a:p>
+            <a:pPr>
+              <a:spcAft>
+                <a:spcPts val="600"/>
+              </a:spcAft>
+            </a:pPr>
+            <a:r>
+              <a:rPr sz="1200" b="0">
+                <a:solidFill>
+                  <a:srgbClr val="282828"/>
+                </a:solidFill>
+                <a:latin typeface="Arial"/>
+              </a:rPr>
+              <a:t>•  </a:t>
+            </a:r>
+            <a:r>
+              <a:rPr sz="1200" b="1">
+                <a:solidFill>
+                  <a:srgbClr val="282828"/>
+                </a:solidFill>
+                <a:latin typeface="Arial"/>
+              </a:rPr>
+              <a:t>The built benches on the axis.</a:t>
+            </a:r>
+            <a:r>
+              <a:rPr sz="1200" b="0">
+                <a:solidFill>
+                  <a:srgbClr val="282828"/>
+                </a:solidFill>
+                <a:latin typeface="Arial"/>
+              </a:rPr>
+              <a:t>  The rigorous tool (tg96_pupilsim, engine-traced) gives each leg's transfer at the actuator Nyquist frequency: 0.9999 (lens rig), 0.9994 (mirror rig).  The Gaussian with the same transfer has σ = 0.006 and 0.016 pitch — where they sit on the curves.</a:t>
+            </a:r>
+          </a:p>
+        </p:txBody>
+      </p:sp>
+      <p:sp>
+        <p:nvSpPr>
+          <p:cNvPr id="6" name="TextBox 5"/>
+          <p:cNvSpPr txBox="1"/>
+          <p:nvPr/>
+        </p:nvSpPr>
+        <p:spPr>
+          <a:xfrm>
+            <a:off x="6400800" y="4389120"/>
+            <a:ext cx="5394960" cy="274320"/>
+          </a:xfrm>
+          <a:prstGeom prst="rect">
+            <a:avLst/>
+          </a:prstGeom>
+          <a:noFill/>
+        </p:spPr>
+        <p:txBody>
+          <a:bodyPr wrap="square">
+            <a:spAutoFit/>
+          </a:bodyPr>
+          <a:lstStyle/>
+          <a:p>
+            <a:pPr>
+              <a:spcAft>
+                <a:spcPts val="600"/>
+              </a:spcAft>
+            </a:pPr>
+            <a:r>
               <a:rPr sz="1050" b="0">
                 <a:solidFill>
                   <a:srgbClr val="6E6E6E"/>
                 </a:solidFill>
                 <a:latin typeface="Arial"/>
               </a:rPr>
-              <a:t>pupil_blur_demo_steps.png, top row; the "steps figure" line of the report.</a:t>
+              <a:t>pupil_blur_demo.m (templates/40_benches/tg_psi_dm96_oap/), ~1 min, no engine; record runs/pupil_blur_demo/pupil_blur_demo_report.txt.  Approximations: the blur acts on the phase map (the small-phase limit, 0.1 wave here); the legs are matched to a Gaussian at the Nyquist transfer only.</a:t>
+            </a:r>
+          </a:p>
+        </p:txBody>
+      </p:sp>
+    </p:spTree>
+  </p:cSld>
+  <p:clrMapOvr>
+    <a:masterClrMapping/>
+  </p:clrMapOvr>
+</p:sld>
+</file>
+
+<file path=ppt/slides/slide3.xml><?xml version="1.0" encoding="utf-8"?>
+<p:sld xmlns:a="http://schemas.openxmlformats.org/drawingml/2006/main" xmlns:p="http://schemas.openxmlformats.org/presentationml/2006/main" xmlns:r="http://schemas.openxmlformats.org/officeDocument/2006/relationships">
+  <p:cSld>
+    <p:spTree>
+      <p:nvGrpSpPr>
+        <p:cNvPr id="1" name=""/>
+        <p:cNvGrpSpPr/>
+        <p:nvPr/>
+      </p:nvGrpSpPr>
+      <p:grpSpPr/>
+      <p:sp>
+        <p:nvSpPr>
+          <p:cNvPr id="2" name="TextBox 1"/>
+          <p:cNvSpPr txBox="1"/>
+          <p:nvPr/>
+        </p:nvSpPr>
+        <p:spPr>
+          <a:xfrm>
+            <a:off x="411480" y="201168"/>
+            <a:ext cx="11368735" cy="914400"/>
+          </a:xfrm>
+          <a:prstGeom prst="rect">
+            <a:avLst/>
+          </a:prstGeom>
+          <a:noFill/>
+        </p:spPr>
+        <p:txBody>
+          <a:bodyPr wrap="square">
+            <a:spAutoFit/>
+          </a:bodyPr>
+          <a:lstStyle/>
+          <a:p>
+            <a:pPr>
+              <a:spcAft>
+                <a:spcPts val="400"/>
+              </a:spcAft>
+            </a:pPr>
+            <a:r>
+              <a:rPr sz="2400" b="1">
+                <a:solidFill>
+                  <a:srgbClr val="1F4E79"/>
+                </a:solidFill>
+                <a:latin typeface="Arial"/>
+              </a:rPr>
+              <a:t>Step by step, plain least squares</a:t>
+            </a:r>
+          </a:p>
+          <a:p>
+            <a:pPr>
+              <a:spcAft>
+                <a:spcPts val="0"/>
+              </a:spcAft>
+            </a:pPr>
+            <a:r>
+              <a:rPr sz="1250" b="0">
+                <a:solidFill>
+                  <a:srgbClr val="6E6E6E"/>
+                </a:solidFill>
+                <a:latin typeface="Arial"/>
+              </a:rPr>
+              <a:t>The 30 nm working surface blurred at σ = 0.5 pitch (54 % transfer at the actuator Nyquist): read without calibration the estimate is the blurred surface; read with calibration it is the true one; one gray scale for all four panels, the error on the same scale</a:t>
+            </a:r>
+          </a:p>
+        </p:txBody>
+      </p:sp>
+      <p:sp>
+        <p:nvSpPr>
+          <p:cNvPr id="3" name="Rectangle 2"/>
+          <p:cNvSpPr/>
+          <p:nvPr/>
+        </p:nvSpPr>
+        <p:spPr>
+          <a:xfrm>
+            <a:off x="411480" y="1133856"/>
+            <a:ext cx="11368735" cy="20320"/>
+          </a:xfrm>
+          <a:prstGeom prst="rect">
+            <a:avLst/>
+          </a:prstGeom>
+          <a:solidFill>
+            <a:srgbClr val="B8C6D4"/>
+          </a:solidFill>
+          <a:ln>
+            <a:noFill/>
+          </a:ln>
+          <a:effectLst/>
+        </p:spPr>
+        <p:style>
+          <a:lnRef idx="1">
+            <a:schemeClr val="accent1"/>
+          </a:lnRef>
+          <a:fillRef idx="3">
+            <a:schemeClr val="accent1"/>
+          </a:fillRef>
+          <a:effectRef idx="2">
+            <a:schemeClr val="accent1"/>
+          </a:effectRef>
+          <a:fontRef idx="minor">
+            <a:schemeClr val="lt1"/>
+          </a:fontRef>
+        </p:style>
+        <p:txBody>
+          <a:bodyPr rtlCol="0" anchor="ctr"/>
+          <a:lstStyle/>
+          <a:p>
+            <a:pPr algn="ctr"/>
+          </a:p>
+        </p:txBody>
+      </p:sp>
+      <p:pic>
+        <p:nvPicPr>
+          <p:cNvPr id="4" name="Picture 3" descr="blur_steps_lsq.png"/>
+          <p:cNvPicPr>
+            <a:picLocks noChangeAspect="1"/>
+          </p:cNvPicPr>
+          <p:nvPr/>
+        </p:nvPicPr>
+        <p:blipFill>
+          <a:blip r:embed="rId2"/>
+          <a:stretch>
+            <a:fillRect/>
+          </a:stretch>
+        </p:blipFill>
+        <p:spPr>
+          <a:xfrm>
+            <a:off x="1392164" y="1298448"/>
+            <a:ext cx="9407365" cy="3537712"/>
+          </a:xfrm>
+          <a:prstGeom prst="rect">
+            <a:avLst/>
+          </a:prstGeom>
+        </p:spPr>
+      </p:pic>
+      <p:sp>
+        <p:nvSpPr>
+          <p:cNvPr id="5" name="TextBox 4"/>
+          <p:cNvSpPr txBox="1"/>
+          <p:nvPr/>
+        </p:nvSpPr>
+        <p:spPr>
+          <a:xfrm>
+            <a:off x="411480" y="4854447"/>
+            <a:ext cx="11368735" cy="394208"/>
+          </a:xfrm>
+          <a:prstGeom prst="rect">
+            <a:avLst/>
+          </a:prstGeom>
+          <a:noFill/>
+        </p:spPr>
+        <p:txBody>
+          <a:bodyPr wrap="square">
+            <a:spAutoFit/>
+          </a:bodyPr>
+          <a:lstStyle/>
+          <a:p>
+            <a:pPr algn="ctr">
+              <a:spcAft>
+                <a:spcPts val="0"/>
+              </a:spcAft>
+            </a:pPr>
+            <a:r>
+              <a:rPr sz="1000" b="0">
+                <a:solidFill>
+                  <a:srgbClr val="6E6E6E"/>
+                </a:solidFill>
+                <a:latin typeface="Arial"/>
+              </a:rPr>
+              <a:t>Rows: the read without calibration, then with.  Columns: the true surface; the blurred surface the camera sees; the surface rebuilt from the recovered commands; the error, reconstructed − true.  Center 24 × 24 pitches of the 96 × 96 DM, one gray scale (±120 nm).</a:t>
+            </a:r>
+          </a:p>
+        </p:txBody>
+      </p:sp>
+      <p:sp>
+        <p:nvSpPr>
+          <p:cNvPr id="6" name="TextBox 5"/>
+          <p:cNvSpPr txBox="1"/>
+          <p:nvPr/>
+        </p:nvSpPr>
+        <p:spPr>
+          <a:xfrm>
+            <a:off x="411480" y="5285231"/>
+            <a:ext cx="11368735" cy="274320"/>
+          </a:xfrm>
+          <a:prstGeom prst="rect">
+            <a:avLst/>
+          </a:prstGeom>
+          <a:noFill/>
+        </p:spPr>
+        <p:txBody>
+          <a:bodyPr wrap="square">
+            <a:spAutoFit/>
+          </a:bodyPr>
+          <a:lstStyle/>
+          <a:p>
+            <a:pPr>
+              <a:spcAft>
+                <a:spcPts val="600"/>
+              </a:spcAft>
+            </a:pPr>
+            <a:r>
+              <a:rPr sz="1500" b="0">
+                <a:solidFill>
+                  <a:srgbClr val="282828"/>
+                </a:solidFill>
+                <a:latin typeface="Arial"/>
+              </a:rPr>
+              <a:t>•  </a:t>
+            </a:r>
+            <a:r>
+              <a:rPr sz="1500" b="1">
+                <a:solidFill>
+                  <a:srgbClr val="282828"/>
+                </a:solidFill>
+                <a:latin typeface="Arial"/>
+              </a:rPr>
+              <a:t>Without calibration</a:t>
+            </a:r>
+            <a:r>
+              <a:rPr sz="1500" b="0">
+                <a:solidFill>
+                  <a:srgbClr val="282828"/>
+                </a:solidFill>
+                <a:latin typeface="Arial"/>
+              </a:rPr>
+              <a:t> the read is faithful to the wrong thing: it reproduces the blurred surface (37 % command error; 5.1 nm rms from the true, which is the blurred surface's own 5.2 nm).  </a:t>
+            </a:r>
+            <a:r>
+              <a:rPr sz="1500" b="1">
+                <a:solidFill>
+                  <a:srgbClr val="282828"/>
+                </a:solidFill>
+                <a:latin typeface="Arial"/>
+              </a:rPr>
+              <a:t>With calibration</a:t>
+            </a:r>
+            <a:r>
+              <a:rPr sz="1500" b="0">
+                <a:solidFill>
+                  <a:srgbClr val="282828"/>
+                </a:solidFill>
+                <a:latin typeface="Arial"/>
+              </a:rPr>
+              <a:t> the blur is in the forward model and the inversion undoes it: 0.09 %, 7 pm rms — the 20 pm read noise is the only residual.</a:t>
+            </a:r>
+          </a:p>
+        </p:txBody>
+      </p:sp>
+      <p:sp>
+        <p:nvSpPr>
+          <p:cNvPr id="7" name="TextBox 6"/>
+          <p:cNvSpPr txBox="1"/>
+          <p:nvPr/>
+        </p:nvSpPr>
+        <p:spPr>
+          <a:xfrm>
+            <a:off x="411480" y="6204965"/>
+            <a:ext cx="11368735" cy="274320"/>
+          </a:xfrm>
+          <a:prstGeom prst="rect">
+            <a:avLst/>
+          </a:prstGeom>
+          <a:noFill/>
+        </p:spPr>
+        <p:txBody>
+          <a:bodyPr wrap="square">
+            <a:spAutoFit/>
+          </a:bodyPr>
+          <a:lstStyle/>
+          <a:p>
+            <a:pPr>
+              <a:spcAft>
+                <a:spcPts val="600"/>
+              </a:spcAft>
+            </a:pPr>
+            <a:r>
+              <a:rPr sz="1050" b="0">
+                <a:solidFill>
+                  <a:srgbClr val="6E6E6E"/>
+                </a:solidFill>
+                <a:latin typeface="Arial"/>
+              </a:rPr>
+              <a:t>pupil_blur_demo_steps.png, rows 1–2; the "steps figure" line of the report.</a:t>
             </a:r>
           </a:p>
         </p:txBody>
@@ -5667,7 +6082,7 @@
                 </a:solidFill>
                 <a:latin typeface="Arial"/>
               </a:rPr>
-              <a:t>Step by step, the gauge's own reconstructor</a:t>
+              <a:t>Step by step, the gauge's reconstructor, one step</a:t>
             </a:r>
           </a:p>
           <a:p>
@@ -5683,7 +6098,7 @@
                 </a:solidFill>
                 <a:latin typeface="Arial"/>
               </a:rPr>
-              <a:t>The same surface and blur through the regularized read the deck used: calibration still removes most of the blur, but the regularization's floor shows</a:t>
+              <a:t>The same surface and blur through the regularized read the gauge deck used, applied once: the shrinkage shows — and it is not the estimator's accuracy</a:t>
             </a:r>
           </a:p>
         </p:txBody>
@@ -5748,8 +6163,8 @@
         </p:blipFill>
         <p:spPr>
           <a:xfrm>
-            <a:off x="411480" y="1298448"/>
-            <a:ext cx="11368735" cy="2320731"/>
+            <a:off x="1147403" y="1298448"/>
+            <a:ext cx="9896888" cy="3702811"/>
           </a:xfrm>
           <a:prstGeom prst="rect">
             <a:avLst/>
@@ -5764,7 +6179,7 @@
         </p:nvSpPr>
         <p:spPr>
           <a:xfrm>
-            <a:off x="411480" y="3637467"/>
+            <a:off x="411480" y="5019547"/>
             <a:ext cx="11368735" cy="229107"/>
           </a:xfrm>
           <a:prstGeom prst="rect">
@@ -5790,251 +6205,20 @@
                 </a:solidFill>
                 <a:latin typeface="Arial"/>
               </a:rPr>
-              <a:t>The same four panels with the record's estimator (λ_m = 10⁻³).</a:t>
-            </a:r>
-          </a:p>
-        </p:txBody>
-      </p:sp>
-      <p:graphicFrame>
-        <p:nvGraphicFramePr>
-          <p:cNvPr id="6" name="Table 5"/>
-          <p:cNvGraphicFramePr>
-            <a:graphicFrameLocks noGrp="1"/>
-          </p:cNvGraphicFramePr>
-          <p:nvPr/>
-        </p:nvGraphicFramePr>
-        <p:xfrm>
-          <a:off x="411480" y="3903151"/>
-          <a:ext cx="11368735" cy="840105"/>
-        </p:xfrm>
-        <a:graphic>
-          <a:graphicData uri="http://schemas.openxmlformats.org/drawingml/2006/table">
-            <a:tbl>
-              <a:tblPr firstRow="1" bandRow="1">
-                <a:tableStyleId>{5C22544A-7EE6-4342-B048-85BDC9FD1C3A}</a:tableStyleId>
-              </a:tblPr>
-              <a:tblGrid>
-                <a:gridCol w="8025079"/>
-                <a:gridCol w="1090676"/>
-                <a:gridCol w="2252980"/>
-              </a:tblGrid>
-              <a:tr h="280035">
-                <a:tc>
-                  <a:txBody>
-                    <a:bodyPr wrap="square"/>
-                    <a:lstStyle/>
-                    <a:p>
-                      <a:r>
-                        <a:rPr sz="1100" b="1">
-                          <a:solidFill>
-                            <a:srgbClr val="FFFFFF"/>
-                          </a:solidFill>
-                          <a:latin typeface="Arial"/>
-                        </a:rPr>
-                        <a:t>the gauge's reconstructor at σ = 0.5 pitch</a:t>
-                      </a:r>
-                    </a:p>
-                  </a:txBody>
-                  <a:tcPr marL="54864" marR="54864" marT="18288" marB="18288">
-                    <a:solidFill>
-                      <a:srgbClr val="1F4E79"/>
-                    </a:solidFill>
-                  </a:tcPr>
-                </a:tc>
-                <a:tc>
-                  <a:txBody>
-                    <a:bodyPr wrap="square"/>
-                    <a:lstStyle/>
-                    <a:p>
-                      <a:r>
-                        <a:rPr sz="1100" b="1">
-                          <a:solidFill>
-                            <a:srgbClr val="FFFFFF"/>
-                          </a:solidFill>
-                          <a:latin typeface="Arial"/>
-                        </a:rPr>
-                        <a:t>command error</a:t>
-                      </a:r>
-                    </a:p>
-                  </a:txBody>
-                  <a:tcPr marL="54864" marR="54864" marT="18288" marB="18288">
-                    <a:solidFill>
-                      <a:srgbClr val="1F4E79"/>
-                    </a:solidFill>
-                  </a:tcPr>
-                </a:tc>
-                <a:tc>
-                  <a:txBody>
-                    <a:bodyPr wrap="square"/>
-                    <a:lstStyle/>
-                    <a:p>
-                      <a:r>
-                        <a:rPr sz="1100" b="1">
-                          <a:solidFill>
-                            <a:srgbClr val="FFFFFF"/>
-                          </a:solidFill>
-                          <a:latin typeface="Arial"/>
-                        </a:rPr>
-                        <a:t>reconstructed surface vs true</a:t>
-                      </a:r>
-                    </a:p>
-                  </a:txBody>
-                  <a:tcPr marL="54864" marR="54864" marT="18288" marB="18288">
-                    <a:solidFill>
-                      <a:srgbClr val="1F4E79"/>
-                    </a:solidFill>
-                  </a:tcPr>
-                </a:tc>
-              </a:tr>
-              <a:tr h="280035">
-                <a:tc>
-                  <a:txBody>
-                    <a:bodyPr wrap="square"/>
-                    <a:lstStyle/>
-                    <a:p>
-                      <a:r>
-                        <a:rPr sz="1100" b="0">
-                          <a:solidFill>
-                            <a:srgbClr val="282828"/>
-                          </a:solidFill>
-                          <a:latin typeface="Arial"/>
-                        </a:rPr>
-                        <a:t>without calibration</a:t>
-                      </a:r>
-                    </a:p>
-                  </a:txBody>
-                  <a:tcPr marL="54864" marR="54864" marT="18288" marB="18288">
-                    <a:solidFill>
-                      <a:srgbClr val="FFFFFF"/>
-                    </a:solidFill>
-                  </a:tcPr>
-                </a:tc>
-                <a:tc>
-                  <a:txBody>
-                    <a:bodyPr wrap="square"/>
-                    <a:lstStyle/>
-                    <a:p>
-                      <a:r>
-                        <a:rPr sz="1100" b="0">
-                          <a:solidFill>
-                            <a:srgbClr val="282828"/>
-                          </a:solidFill>
-                          <a:latin typeface="Arial"/>
-                        </a:rPr>
-                        <a:t>37 %</a:t>
-                      </a:r>
-                    </a:p>
-                  </a:txBody>
-                  <a:tcPr marL="54864" marR="54864" marT="18288" marB="18288">
-                    <a:solidFill>
-                      <a:srgbClr val="FFFFFF"/>
-                    </a:solidFill>
-                  </a:tcPr>
-                </a:tc>
-                <a:tc>
-                  <a:txBody>
-                    <a:bodyPr wrap="square"/>
-                    <a:lstStyle/>
-                    <a:p>
-                      <a:r>
-                        <a:rPr sz="1100" b="0">
-                          <a:solidFill>
-                            <a:srgbClr val="282828"/>
-                          </a:solidFill>
-                          <a:latin typeface="Arial"/>
-                        </a:rPr>
-                        <a:t>5.2 nm rms</a:t>
-                      </a:r>
-                    </a:p>
-                  </a:txBody>
-                  <a:tcPr marL="54864" marR="54864" marT="18288" marB="18288">
-                    <a:solidFill>
-                      <a:srgbClr val="FFFFFF"/>
-                    </a:solidFill>
-                  </a:tcPr>
-                </a:tc>
-              </a:tr>
-              <a:tr h="280035">
-                <a:tc>
-                  <a:txBody>
-                    <a:bodyPr wrap="square"/>
-                    <a:lstStyle/>
-                    <a:p>
-                      <a:r>
-                        <a:rPr sz="1100" b="0">
-                          <a:solidFill>
-                            <a:srgbClr val="282828"/>
-                          </a:solidFill>
-                          <a:latin typeface="Arial"/>
-                        </a:rPr>
-                        <a:t>with calibration</a:t>
-                      </a:r>
-                    </a:p>
-                  </a:txBody>
-                  <a:tcPr marL="54864" marR="54864" marT="18288" marB="18288">
-                    <a:solidFill>
-                      <a:srgbClr val="ECF1F6"/>
-                    </a:solidFill>
-                  </a:tcPr>
-                </a:tc>
-                <a:tc>
-                  <a:txBody>
-                    <a:bodyPr wrap="square"/>
-                    <a:lstStyle/>
-                    <a:p>
-                      <a:r>
-                        <a:rPr sz="1100" b="0">
-                          <a:solidFill>
-                            <a:srgbClr val="282828"/>
-                          </a:solidFill>
-                          <a:latin typeface="Arial"/>
-                        </a:rPr>
-                        <a:t>4.8 %</a:t>
-                      </a:r>
-                    </a:p>
-                  </a:txBody>
-                  <a:tcPr marL="54864" marR="54864" marT="18288" marB="18288">
-                    <a:solidFill>
-                      <a:srgbClr val="ECF1F6"/>
-                    </a:solidFill>
-                  </a:tcPr>
-                </a:tc>
-                <a:tc>
-                  <a:txBody>
-                    <a:bodyPr wrap="square"/>
-                    <a:lstStyle/>
-                    <a:p>
-                      <a:r>
-                        <a:rPr sz="1100" b="0">
-                          <a:solidFill>
-                            <a:srgbClr val="282828"/>
-                          </a:solidFill>
-                          <a:latin typeface="Arial"/>
-                        </a:rPr>
-                        <a:t>0.23 nm rms</a:t>
-                      </a:r>
-                    </a:p>
-                  </a:txBody>
-                  <a:tcPr marL="54864" marR="54864" marT="18288" marB="18288">
-                    <a:solidFill>
-                      <a:srgbClr val="ECF1F6"/>
-                    </a:solidFill>
-                  </a:tcPr>
-                </a:tc>
-              </a:tr>
-            </a:tbl>
-          </a:graphicData>
-        </a:graphic>
-      </p:graphicFrame>
-      <p:sp>
-        <p:nvSpPr>
-          <p:cNvPr id="7" name="TextBox 6"/>
+              <a:t>The same layout with the record's estimator (λ_m = 10⁻³), one step.</a:t>
+            </a:r>
+          </a:p>
+        </p:txBody>
+      </p:sp>
+      <p:sp>
+        <p:nvSpPr>
+          <p:cNvPr id="6" name="TextBox 5"/>
           <p:cNvSpPr txBox="1"/>
           <p:nvPr/>
         </p:nvSpPr>
         <p:spPr>
           <a:xfrm>
-            <a:off x="411480" y="4889560"/>
+            <a:off x="411480" y="5285231"/>
             <a:ext cx="11368735" cy="274320"/>
           </a:xfrm>
           <a:prstGeom prst="rect">
@@ -6069,7 +6253,7 @@
                 </a:solidFill>
                 <a:latin typeface="Arial"/>
               </a:rPr>
-              <a:t>The 4.8 % is the regularization, not the blur:</a:t>
+              <a:t>One step, calibrated: 4.8 %, 0.23 nm rms</a:t>
             </a:r>
             <a:r>
               <a:rPr sz="1500" b="0">
@@ -6078,20 +6262,20 @@
                 </a:solidFill>
                 <a:latin typeface="Arial"/>
               </a:rPr>
-              <a:t> at zero blur this estimator already carries 1.0 % on this surface, and as the blur erases the finest content the fixed weight λ_m bites harder on what is left.  The plain read shows what the data support (0.09 %); the gauge's read shows what its weight chooses to keep.  The weight is a knob — the record's 10⁻³ guards the measured matrix's own noise; the trade is measured on the next slide's backup.</a:t>
-            </a:r>
-          </a:p>
-        </p:txBody>
-      </p:sp>
-      <p:sp>
-        <p:nvSpPr>
-          <p:cNvPr id="8" name="TextBox 7"/>
+              <a:t> against the plain read's 0.09 %.  The difference is the regularization's shrinkage, which already costs 1 % at zero blur and more as the blur erases the finest content.  A single regularized step is a shrunk estimate, not where the estimator converges — the gauge never uses it once; its servo applies it repeatedly (next slide).</a:t>
+            </a:r>
+          </a:p>
+        </p:txBody>
+      </p:sp>
+      <p:sp>
+        <p:nvSpPr>
+          <p:cNvPr id="7" name="TextBox 6"/>
           <p:cNvSpPr txBox="1"/>
           <p:nvPr/>
         </p:nvSpPr>
         <p:spPr>
           <a:xfrm>
-            <a:off x="411480" y="6056944"/>
+            <a:off x="411480" y="6452615"/>
             <a:ext cx="11368735" cy="274320"/>
           </a:xfrm>
           <a:prstGeom prst="rect">
@@ -6117,7 +6301,7 @@
                 </a:solidFill>
                 <a:latin typeface="Arial"/>
               </a:rPr>
-              <a:t>pupil_blur_demo_steps.png, bottom row.</a:t>
+              <a:t>pupil_blur_demo_steps.png, rows 3–4.</a:t>
             </a:r>
           </a:p>
         </p:txBody>
@@ -6174,7 +6358,7 @@
                 </a:solidFill>
                 <a:latin typeface="Arial"/>
               </a:rPr>
-              <a:t>The curves: error against blur width</a:t>
+              <a:t>Step by step, the gauge's reconstructor driven to convergence</a:t>
             </a:r>
           </a:p>
           <a:p>
@@ -6190,7 +6374,7 @@
                 </a:solidFill>
                 <a:latin typeface="Arial"/>
               </a:rPr>
-              <a:t>The uncalibrated read degrades from a twentieth of a pitch; the calibrated plain read holds to about 0.8 pitch and fails at 1.1 when the blur has erased the actuator-scale content; the gauge's reconstructor holds to 0.3–0.4 pitch</a:t>
+              <a:t>Applied as the servo applies it — read the residual, correct, read again — the regularized estimator converges to the plain read's answer, with and even without calibration</a:t>
             </a:r>
           </a:p>
         </p:txBody>
@@ -6241,7 +6425,7 @@
       </p:sp>
       <p:pic>
         <p:nvPicPr>
-          <p:cNvPr id="4" name="Picture 3" descr="blur_curve_random.png"/>
+          <p:cNvPr id="4" name="Picture 3" descr="blur_steps_iter.png"/>
           <p:cNvPicPr>
             <a:picLocks noChangeAspect="1"/>
           </p:cNvPicPr>
@@ -6255,8 +6439,8 @@
         </p:blipFill>
         <p:spPr>
           <a:xfrm>
-            <a:off x="1860189" y="1298448"/>
-            <a:ext cx="2909021" cy="2567432"/>
+            <a:off x="1182500" y="1298448"/>
+            <a:ext cx="9826693" cy="3702811"/>
           </a:xfrm>
           <a:prstGeom prst="rect">
             <a:avLst/>
@@ -6271,8 +6455,8 @@
         </p:nvSpPr>
         <p:spPr>
           <a:xfrm>
-            <a:off x="411480" y="3884167"/>
-            <a:ext cx="5806440" cy="724408"/>
+            <a:off x="411480" y="5019547"/>
+            <a:ext cx="11368735" cy="229107"/>
           </a:xfrm>
           <a:prstGeom prst="rect">
             <a:avLst/>
@@ -6297,84 +6481,21 @@
                 </a:solidFill>
                 <a:latin typeface="Arial"/>
               </a:rPr>
-              <a:t>The random 30 nm working surface: command error vs blur 1/e radius in actuator pitches.  Dashed gray: plain least squares; black: the record's reconstructor; blue dotted: the bench's kernel estimator.  Open = without calibration, filled = with.  The shaded band is the width the gauge deck stated for its legs.</a:t>
-            </a:r>
-          </a:p>
-        </p:txBody>
-      </p:sp>
-      <p:pic>
-        <p:nvPicPr>
-          <p:cNvPr id="6" name="Picture 5" descr="blur_curve_checker.png"/>
-          <p:cNvPicPr>
-            <a:picLocks noChangeAspect="1"/>
-          </p:cNvPicPr>
-          <p:nvPr/>
-        </p:nvPicPr>
-        <p:blipFill>
-          <a:blip r:embed="rId3"/>
-          <a:stretch>
-            <a:fillRect/>
-          </a:stretch>
-        </p:blipFill>
-        <p:spPr>
-          <a:xfrm>
-            <a:off x="7466814" y="1298448"/>
-            <a:ext cx="3262931" cy="2897632"/>
-          </a:xfrm>
-          <a:prstGeom prst="rect">
-            <a:avLst/>
-          </a:prstGeom>
-        </p:spPr>
-      </p:pic>
-      <p:sp>
-        <p:nvSpPr>
-          <p:cNvPr id="7" name="TextBox 6"/>
+              <a:t>The same layout, the record's estimator iterated 20 times at gain 1: a_{k+1} = a_k + est(m − blur(surface(a_k))).</a:t>
+            </a:r>
+          </a:p>
+        </p:txBody>
+      </p:sp>
+      <p:sp>
+        <p:nvSpPr>
+          <p:cNvPr id="6" name="TextBox 5"/>
           <p:cNvSpPr txBox="1"/>
           <p:nvPr/>
         </p:nvSpPr>
         <p:spPr>
           <a:xfrm>
-            <a:off x="6400800" y="4214367"/>
-            <a:ext cx="5394960" cy="394208"/>
-          </a:xfrm>
-          <a:prstGeom prst="rect">
-            <a:avLst/>
-          </a:prstGeom>
-          <a:noFill/>
-        </p:spPr>
-        <p:txBody>
-          <a:bodyPr wrap="square">
-            <a:spAutoFit/>
-          </a:bodyPr>
-          <a:lstStyle/>
-          <a:p>
-            <a:pPr algn="ctr">
-              <a:spcAft>
-                <a:spcPts val="0"/>
-              </a:spcAft>
-            </a:pPr>
-            <a:r>
-              <a:rPr sz="1000" b="0">
-                <a:solidFill>
-                  <a:srgbClr val="6E6E6E"/>
-                </a:solidFill>
-                <a:latin typeface="Arial"/>
-              </a:rPr>
-              <a:t>The ±50 nm checkerboard — the actuator Nyquist pattern, the first thing blur removes.</a:t>
-            </a:r>
-          </a:p>
-        </p:txBody>
-      </p:sp>
-      <p:sp>
-        <p:nvSpPr>
-          <p:cNvPr id="8" name="TextBox 7"/>
-          <p:cNvSpPr txBox="1"/>
-          <p:nvPr/>
-        </p:nvSpPr>
-        <p:spPr>
-          <a:xfrm>
-            <a:off x="6400800" y="4645151"/>
-            <a:ext cx="5394960" cy="274320"/>
+            <a:off x="411480" y="5285231"/>
+            <a:ext cx="11368735" cy="274320"/>
           </a:xfrm>
           <a:prstGeom prst="rect">
             <a:avLst/>
@@ -6393,7 +6514,7 @@
               </a:spcAft>
             </a:pPr>
             <a:r>
-              <a:rPr sz="1200" b="0">
+              <a:rPr sz="1500" b="0">
                 <a:solidFill>
                   <a:srgbClr val="282828"/>
                 </a:solidFill>
@@ -6402,24 +6523,65 @@
               <a:t>•  </a:t>
             </a:r>
             <a:r>
-              <a:rPr sz="1200" b="1">
-                <a:solidFill>
-                  <a:srgbClr val="282828"/>
-                </a:solidFill>
-                <a:latin typeface="Arial"/>
-              </a:rPr>
-              <a:t>Uncalibrated:</a:t>
-            </a:r>
-            <a:r>
-              <a:rPr sz="1200" b="0">
-                <a:solidFill>
-                  <a:srgbClr val="282828"/>
-                </a:solidFill>
-                <a:latin typeface="Arial"/>
-              </a:rPr>
-              <a:t> 2 % at 0.1 pitch, 8 % at 0.2, 37 % at 0.5 (random surface); the checkerboard is half gone at 0.4.</a:t>
-            </a:r>
-          </a:p>
+              <a:rPr sz="1500" b="1">
+                <a:solidFill>
+                  <a:srgbClr val="282828"/>
+                </a:solidFill>
+                <a:latin typeface="Arial"/>
+              </a:rPr>
+              <a:t>Converged, calibrated: 0.087 %, 7 pm</a:t>
+            </a:r>
+            <a:r>
+              <a:rPr sz="1500" b="0">
+                <a:solidFill>
+                  <a:srgbClr val="282828"/>
+                </a:solidFill>
+                <a:latin typeface="Arial"/>
+              </a:rPr>
+              <a:t> — the plain least-squares answer; the regularization set the convergence rate, not the accuracy.  </a:t>
+            </a:r>
+            <a:r>
+              <a:rPr sz="1500" b="1">
+                <a:solidFill>
+                  <a:srgbClr val="282828"/>
+                </a:solidFill>
+                <a:latin typeface="Arial"/>
+              </a:rPr>
+              <a:t>Converged, uncalibrated: 0.09 %, 7 pm as well</a:t>
+            </a:r>
+            <a:r>
+              <a:rPr sz="1500" b="0">
+                <a:solidFill>
+                  <a:srgbClr val="282828"/>
+                </a:solidFill>
+                <a:latin typeface="Arial"/>
+              </a:rPr>
+              <a:t> — the blur is in the loop's plant, so the loop corrects what the camera sees until the camera sees nothing, and a blurred residual of zero is a residual of zero for every frequency the blur passes.  Calibration matters for a one-shot read (a capture, an absolute measurement); for hold it sets the stability margin: the uncalibrated loop over-corrects the attenuated frequencies and diverges beyond 0.6 pitch of blur (next slide).</a:t>
+            </a:r>
+          </a:p>
+        </p:txBody>
+      </p:sp>
+      <p:sp>
+        <p:nvSpPr>
+          <p:cNvPr id="7" name="TextBox 6"/>
+          <p:cNvSpPr txBox="1"/>
+          <p:nvPr/>
+        </p:nvSpPr>
+        <p:spPr>
+          <a:xfrm>
+            <a:off x="411480" y="6947915"/>
+            <a:ext cx="11368735" cy="274320"/>
+          </a:xfrm>
+          <a:prstGeom prst="rect">
+            <a:avLst/>
+          </a:prstGeom>
+          <a:noFill/>
+        </p:spPr>
+        <p:txBody>
+          <a:bodyPr wrap="square">
+            <a:spAutoFit/>
+          </a:bodyPr>
+          <a:lstStyle/>
           <a:p>
             <a:pPr>
               <a:spcAft>
@@ -6427,104 +6589,13 @@
               </a:spcAft>
             </a:pPr>
             <a:r>
-              <a:rPr sz="1200" b="0">
-                <a:solidFill>
-                  <a:srgbClr val="282828"/>
-                </a:solidFill>
-                <a:latin typeface="Arial"/>
-              </a:rPr>
-              <a:t>•  </a:t>
-            </a:r>
-            <a:r>
-              <a:rPr sz="1200" b="1">
-                <a:solidFill>
-                  <a:srgbClr val="282828"/>
-                </a:solidFill>
-                <a:latin typeface="Arial"/>
-              </a:rPr>
-              <a:t>Calibrated, plain:</a:t>
-            </a:r>
-            <a:r>
-              <a:rPr sz="1200" b="0">
-                <a:solidFill>
-                  <a:srgbClr val="282828"/>
-                </a:solidFill>
-                <a:latin typeface="Arial"/>
-              </a:rPr>
-              <a:t> at the noise floor (0.04 %) to 0.5 pitch, 0.35 % at 0.8, then the matrix turns ill-conditioned (the transfer at Nyquist is 8 % at 1.0 pitch, 5 % at 1.1) and the read collapses by 1.3.</a:t>
-            </a:r>
-          </a:p>
-          <a:p>
-            <a:pPr>
-              <a:spcAft>
-                <a:spcPts val="600"/>
-              </a:spcAft>
-            </a:pPr>
-            <a:r>
-              <a:rPr sz="1200" b="0">
-                <a:solidFill>
-                  <a:srgbClr val="282828"/>
-                </a:solidFill>
-                <a:latin typeface="Arial"/>
-              </a:rPr>
-              <a:t>•  </a:t>
-            </a:r>
-            <a:r>
-              <a:rPr sz="1200" b="1">
-                <a:solidFill>
-                  <a:srgbClr val="282828"/>
-                </a:solidFill>
-                <a:latin typeface="Arial"/>
-              </a:rPr>
-              <a:t>Calibrated, the gauge's:</a:t>
-            </a:r>
-            <a:r>
-              <a:rPr sz="1200" b="0">
-                <a:solidFill>
-                  <a:srgbClr val="282828"/>
-                </a:solidFill>
-                <a:latin typeface="Arial"/>
-              </a:rPr>
-              <a:t> 1.3 % at 0.2 pitch, 2.8 % at 0.4, 4.8 % at 0.5 — the floor plus the regularization's growing share.</a:t>
-            </a:r>
-          </a:p>
-        </p:txBody>
-      </p:sp>
-      <p:sp>
-        <p:nvSpPr>
-          <p:cNvPr id="9" name="TextBox 8"/>
-          <p:cNvSpPr txBox="1"/>
-          <p:nvPr/>
-        </p:nvSpPr>
-        <p:spPr>
-          <a:xfrm>
-            <a:off x="6400800" y="6489192"/>
-            <a:ext cx="5394960" cy="274320"/>
-          </a:xfrm>
-          <a:prstGeom prst="rect">
-            <a:avLst/>
-          </a:prstGeom>
-          <a:noFill/>
-        </p:spPr>
-        <p:txBody>
-          <a:bodyPr wrap="square">
-            <a:spAutoFit/>
-          </a:bodyPr>
-          <a:lstStyle/>
-          <a:p>
-            <a:pPr>
-              <a:spcAft>
-                <a:spcPts val="600"/>
-              </a:spcAft>
-            </a:pPr>
-            <a:r>
               <a:rPr sz="1050" b="0">
                 <a:solidFill>
                   <a:srgbClr val="6E6E6E"/>
                 </a:solidFill>
                 <a:latin typeface="Arial"/>
               </a:rPr>
-              <a:t>pupil_blur_demo_curve.png, top-left two panels; the sweep tables in the report.</a:t>
+              <a:t>pupil_blur_demo_steps.png, rows 5–6; the "ITERATED TO CONVERGENCE" sweep in the report.</a:t>
             </a:r>
           </a:p>
         </p:txBody>
@@ -6581,7 +6652,7 @@
                 </a:solidFill>
                 <a:latin typeface="Arial"/>
               </a:rPr>
-              <a:t>Where the built benches sit</a:t>
+              <a:t>The checkerboard, the hardest pattern</a:t>
             </a:r>
           </a:p>
           <a:p>
@@ -6597,7 +6668,7 @@
                 </a:solidFill>
                 <a:latin typeface="Arial"/>
               </a:rPr>
-              <a:t>Both legs are at a hundredth of a pitch, where the uncalibrated cost is a few hundredths of a percent and the calibrated cost is unmeasurable — so the 0.13 / 0.29 % the gauge deck attributed to "blur" is mostly something else</a:t>
+              <a:t>±50 nm on alternate actuators is only ±13 nm of surface (neighboring bumps cancel); blurred at 0.5 pitch it nearly vanishes; the uncalibrated read returns the faint version, the calibrated read the full one</a:t>
             </a:r>
           </a:p>
         </p:txBody>
@@ -6648,6 +6719,634 @@
       </p:sp>
       <p:pic>
         <p:nvPicPr>
+          <p:cNvPr id="4" name="Picture 3" descr="blur_maps_checker.png"/>
+          <p:cNvPicPr>
+            <a:picLocks noChangeAspect="1"/>
+          </p:cNvPicPr>
+          <p:nvPr/>
+        </p:nvPicPr>
+        <p:blipFill>
+          <a:blip r:embed="rId2"/>
+          <a:stretch>
+            <a:fillRect/>
+          </a:stretch>
+        </p:blipFill>
+        <p:spPr>
+          <a:xfrm>
+            <a:off x="1681556" y="1298448"/>
+            <a:ext cx="8828582" cy="3885692"/>
+          </a:xfrm>
+          <a:prstGeom prst="rect">
+            <a:avLst/>
+          </a:prstGeom>
+        </p:spPr>
+      </p:pic>
+      <p:sp>
+        <p:nvSpPr>
+          <p:cNvPr id="5" name="TextBox 4"/>
+          <p:cNvSpPr txBox="1"/>
+          <p:nvPr/>
+        </p:nvSpPr>
+        <p:spPr>
+          <a:xfrm>
+            <a:off x="411480" y="5202427"/>
+            <a:ext cx="11368735" cy="229107"/>
+          </a:xfrm>
+          <a:prstGeom prst="rect">
+            <a:avLst/>
+          </a:prstGeom>
+          <a:noFill/>
+        </p:spPr>
+        <p:txBody>
+          <a:bodyPr wrap="square">
+            <a:spAutoFit/>
+          </a:bodyPr>
+          <a:lstStyle/>
+          <a:p>
+            <a:pPr algn="ctr">
+              <a:spcAft>
+                <a:spcPts val="0"/>
+              </a:spcAft>
+            </a:pPr>
+            <a:r>
+              <a:rPr sz="1000" b="0">
+                <a:solidFill>
+                  <a:srgbClr val="6E6E6E"/>
+                </a:solidFill>
+                <a:latin typeface="Arial"/>
+              </a:rPr>
+              <a:t>The ±50 nm checkerboard (the actuator Nyquist pattern) at σ = 0.5 pitch, plain least squares, rows without / with calibration, one gray scale (±13 nm).</a:t>
+            </a:r>
+          </a:p>
+        </p:txBody>
+      </p:sp>
+      <p:sp>
+        <p:nvSpPr>
+          <p:cNvPr id="6" name="TextBox 5"/>
+          <p:cNvSpPr txBox="1"/>
+          <p:nvPr/>
+        </p:nvSpPr>
+        <p:spPr>
+          <a:xfrm>
+            <a:off x="411480" y="5468112"/>
+            <a:ext cx="11368735" cy="274320"/>
+          </a:xfrm>
+          <a:prstGeom prst="rect">
+            <a:avLst/>
+          </a:prstGeom>
+          <a:noFill/>
+        </p:spPr>
+        <p:txBody>
+          <a:bodyPr wrap="square">
+            <a:spAutoFit/>
+          </a:bodyPr>
+          <a:lstStyle/>
+          <a:p>
+            <a:pPr>
+              <a:spcAft>
+                <a:spcPts val="600"/>
+              </a:spcAft>
+            </a:pPr>
+            <a:r>
+              <a:rPr sz="1050" b="0">
+                <a:solidFill>
+                  <a:srgbClr val="6E6E6E"/>
+                </a:solidFill>
+                <a:latin typeface="Arial"/>
+              </a:rPr>
+              <a:t>pupil_blur_demo_maps.png.  Without calibration 68 % command error (4.5 nm rms of surface); with 0.05 % (0.01 nm).</a:t>
+            </a:r>
+          </a:p>
+        </p:txBody>
+      </p:sp>
+    </p:spTree>
+  </p:cSld>
+  <p:clrMapOvr>
+    <a:masterClrMapping/>
+  </p:clrMapOvr>
+</p:sld>
+</file>
+
+<file path=ppt/slides/slide7.xml><?xml version="1.0" encoding="utf-8"?>
+<p:sld xmlns:a="http://schemas.openxmlformats.org/drawingml/2006/main" xmlns:p="http://schemas.openxmlformats.org/presentationml/2006/main" xmlns:r="http://schemas.openxmlformats.org/officeDocument/2006/relationships">
+  <p:cSld>
+    <p:spTree>
+      <p:nvGrpSpPr>
+        <p:cNvPr id="1" name=""/>
+        <p:cNvGrpSpPr/>
+        <p:nvPr/>
+      </p:nvGrpSpPr>
+      <p:grpSpPr/>
+      <p:sp>
+        <p:nvSpPr>
+          <p:cNvPr id="2" name="TextBox 1"/>
+          <p:cNvSpPr txBox="1"/>
+          <p:nvPr/>
+        </p:nvSpPr>
+        <p:spPr>
+          <a:xfrm>
+            <a:off x="411480" y="201168"/>
+            <a:ext cx="11368735" cy="914400"/>
+          </a:xfrm>
+          <a:prstGeom prst="rect">
+            <a:avLst/>
+          </a:prstGeom>
+          <a:noFill/>
+        </p:spPr>
+        <p:txBody>
+          <a:bodyPr wrap="square">
+            <a:spAutoFit/>
+          </a:bodyPr>
+          <a:lstStyle/>
+          <a:p>
+            <a:pPr>
+              <a:spcAft>
+                <a:spcPts val="400"/>
+              </a:spcAft>
+            </a:pPr>
+            <a:r>
+              <a:rPr sz="2400" b="1">
+                <a:solidFill>
+                  <a:srgbClr val="1F4E79"/>
+                </a:solidFill>
+                <a:latin typeface="Arial"/>
+              </a:rPr>
+              <a:t>The curves: error against blur width</a:t>
+            </a:r>
+          </a:p>
+          <a:p>
+            <a:pPr>
+              <a:spcAft>
+                <a:spcPts val="0"/>
+              </a:spcAft>
+            </a:pPr>
+            <a:r>
+              <a:rPr sz="1250" b="0">
+                <a:solidFill>
+                  <a:srgbClr val="6E6E6E"/>
+                </a:solidFill>
+                <a:latin typeface="Arial"/>
+              </a:rPr>
+              <a:t>One-shot reads degrade from a twentieth of a pitch without calibration and hold to about 0.8 pitch with it; the servo converges to the same accuracy with or without calibration until the loop's stability goes, at 0.6 pitch uncalibrated and 0.8 calibrated</a:t>
+            </a:r>
+          </a:p>
+        </p:txBody>
+      </p:sp>
+      <p:sp>
+        <p:nvSpPr>
+          <p:cNvPr id="3" name="Rectangle 2"/>
+          <p:cNvSpPr/>
+          <p:nvPr/>
+        </p:nvSpPr>
+        <p:spPr>
+          <a:xfrm>
+            <a:off x="411480" y="1133856"/>
+            <a:ext cx="11368735" cy="20320"/>
+          </a:xfrm>
+          <a:prstGeom prst="rect">
+            <a:avLst/>
+          </a:prstGeom>
+          <a:solidFill>
+            <a:srgbClr val="B8C6D4"/>
+          </a:solidFill>
+          <a:ln>
+            <a:noFill/>
+          </a:ln>
+          <a:effectLst/>
+        </p:spPr>
+        <p:style>
+          <a:lnRef idx="1">
+            <a:schemeClr val="accent1"/>
+          </a:lnRef>
+          <a:fillRef idx="3">
+            <a:schemeClr val="accent1"/>
+          </a:fillRef>
+          <a:effectRef idx="2">
+            <a:schemeClr val="accent1"/>
+          </a:effectRef>
+          <a:fontRef idx="minor">
+            <a:schemeClr val="lt1"/>
+          </a:fontRef>
+        </p:style>
+        <p:txBody>
+          <a:bodyPr rtlCol="0" anchor="ctr"/>
+          <a:lstStyle/>
+          <a:p>
+            <a:pPr algn="ctr"/>
+          </a:p>
+        </p:txBody>
+      </p:sp>
+      <p:pic>
+        <p:nvPicPr>
+          <p:cNvPr id="4" name="Picture 3" descr="blur_curve_random.png"/>
+          <p:cNvPicPr>
+            <a:picLocks noChangeAspect="1"/>
+          </p:cNvPicPr>
+          <p:nvPr/>
+        </p:nvPicPr>
+        <p:blipFill>
+          <a:blip r:embed="rId2"/>
+          <a:stretch>
+            <a:fillRect/>
+          </a:stretch>
+        </p:blipFill>
+        <p:spPr>
+          <a:xfrm>
+            <a:off x="1911992" y="1298448"/>
+            <a:ext cx="2805415" cy="2475992"/>
+          </a:xfrm>
+          <a:prstGeom prst="rect">
+            <a:avLst/>
+          </a:prstGeom>
+        </p:spPr>
+      </p:pic>
+      <p:sp>
+        <p:nvSpPr>
+          <p:cNvPr id="5" name="TextBox 4"/>
+          <p:cNvSpPr txBox="1"/>
+          <p:nvPr/>
+        </p:nvSpPr>
+        <p:spPr>
+          <a:xfrm>
+            <a:off x="411480" y="3792728"/>
+            <a:ext cx="5806440" cy="724408"/>
+          </a:xfrm>
+          <a:prstGeom prst="rect">
+            <a:avLst/>
+          </a:prstGeom>
+          <a:noFill/>
+        </p:spPr>
+        <p:txBody>
+          <a:bodyPr wrap="square">
+            <a:spAutoFit/>
+          </a:bodyPr>
+          <a:lstStyle/>
+          <a:p>
+            <a:pPr algn="ctr">
+              <a:spcAft>
+                <a:spcPts val="0"/>
+              </a:spcAft>
+            </a:pPr>
+            <a:r>
+              <a:rPr sz="1000" b="0">
+                <a:solidFill>
+                  <a:srgbClr val="6E6E6E"/>
+                </a:solidFill>
+                <a:latin typeface="Arial"/>
+              </a:rPr>
+              <a:t>The random 30 nm working surface: command error vs blur 1/e radius in actuator pitches.  Dashed gray: plain least squares; black: the record's estimator, one step; green: the record's estimator iterated to convergence; blue dotted: the bench's kernel estimator.  Open = without calibration, filled = with.</a:t>
+            </a:r>
+          </a:p>
+        </p:txBody>
+      </p:sp>
+      <p:pic>
+        <p:nvPicPr>
+          <p:cNvPr id="6" name="Picture 5" descr="blur_curve_checker.png"/>
+          <p:cNvPicPr>
+            <a:picLocks noChangeAspect="1"/>
+          </p:cNvPicPr>
+          <p:nvPr/>
+        </p:nvPicPr>
+        <p:blipFill>
+          <a:blip r:embed="rId3"/>
+          <a:stretch>
+            <a:fillRect/>
+          </a:stretch>
+        </p:blipFill>
+        <p:spPr>
+          <a:xfrm>
+            <a:off x="7518297" y="1298448"/>
+            <a:ext cx="3159964" cy="2806192"/>
+          </a:xfrm>
+          <a:prstGeom prst="rect">
+            <a:avLst/>
+          </a:prstGeom>
+        </p:spPr>
+      </p:pic>
+      <p:sp>
+        <p:nvSpPr>
+          <p:cNvPr id="7" name="TextBox 6"/>
+          <p:cNvSpPr txBox="1"/>
+          <p:nvPr/>
+        </p:nvSpPr>
+        <p:spPr>
+          <a:xfrm>
+            <a:off x="6400800" y="4122927"/>
+            <a:ext cx="5394960" cy="394208"/>
+          </a:xfrm>
+          <a:prstGeom prst="rect">
+            <a:avLst/>
+          </a:prstGeom>
+          <a:noFill/>
+        </p:spPr>
+        <p:txBody>
+          <a:bodyPr wrap="square">
+            <a:spAutoFit/>
+          </a:bodyPr>
+          <a:lstStyle/>
+          <a:p>
+            <a:pPr algn="ctr">
+              <a:spcAft>
+                <a:spcPts val="0"/>
+              </a:spcAft>
+            </a:pPr>
+            <a:r>
+              <a:rPr sz="1000" b="0">
+                <a:solidFill>
+                  <a:srgbClr val="6E6E6E"/>
+                </a:solidFill>
+                <a:latin typeface="Arial"/>
+              </a:rPr>
+              <a:t>The ±50 nm checkerboard — the actuator Nyquist pattern, the first thing blur removes.</a:t>
+            </a:r>
+          </a:p>
+        </p:txBody>
+      </p:sp>
+      <p:sp>
+        <p:nvSpPr>
+          <p:cNvPr id="8" name="TextBox 7"/>
+          <p:cNvSpPr txBox="1"/>
+          <p:nvPr/>
+        </p:nvSpPr>
+        <p:spPr>
+          <a:xfrm>
+            <a:off x="6400800" y="4553712"/>
+            <a:ext cx="5394960" cy="274320"/>
+          </a:xfrm>
+          <a:prstGeom prst="rect">
+            <a:avLst/>
+          </a:prstGeom>
+          <a:noFill/>
+        </p:spPr>
+        <p:txBody>
+          <a:bodyPr wrap="square">
+            <a:spAutoFit/>
+          </a:bodyPr>
+          <a:lstStyle/>
+          <a:p>
+            <a:pPr>
+              <a:spcAft>
+                <a:spcPts val="600"/>
+              </a:spcAft>
+            </a:pPr>
+            <a:r>
+              <a:rPr sz="1200" b="0">
+                <a:solidFill>
+                  <a:srgbClr val="282828"/>
+                </a:solidFill>
+                <a:latin typeface="Arial"/>
+              </a:rPr>
+              <a:t>•  </a:t>
+            </a:r>
+            <a:r>
+              <a:rPr sz="1200" b="1">
+                <a:solidFill>
+                  <a:srgbClr val="282828"/>
+                </a:solidFill>
+                <a:latin typeface="Arial"/>
+              </a:rPr>
+              <a:t>One shot, uncalibrated:</a:t>
+            </a:r>
+            <a:r>
+              <a:rPr sz="1200" b="0">
+                <a:solidFill>
+                  <a:srgbClr val="282828"/>
+                </a:solidFill>
+                <a:latin typeface="Arial"/>
+              </a:rPr>
+              <a:t> 2 % at 0.1 pitch, 8 % at 0.2, 37 % at 0.5.  </a:t>
+            </a:r>
+            <a:r>
+              <a:rPr sz="1200" b="1">
+                <a:solidFill>
+                  <a:srgbClr val="282828"/>
+                </a:solidFill>
+                <a:latin typeface="Arial"/>
+              </a:rPr>
+              <a:t>One shot, calibrated, plain:</a:t>
+            </a:r>
+            <a:r>
+              <a:rPr sz="1200" b="0">
+                <a:solidFill>
+                  <a:srgbClr val="282828"/>
+                </a:solidFill>
+                <a:latin typeface="Arial"/>
+              </a:rPr>
+              <a:t> at the noise floor (0.04 %) to 0.5 pitch, 0.35 % at 0.8, collapse by 1.3 when the blur has erased the actuator-scale content (8 % transfer at 1.0 pitch).  </a:t>
+            </a:r>
+            <a:r>
+              <a:rPr sz="1200" b="1">
+                <a:solidFill>
+                  <a:srgbClr val="282828"/>
+                </a:solidFill>
+                <a:latin typeface="Arial"/>
+              </a:rPr>
+              <a:t>One shot, the gauge's, one step:</a:t>
+            </a:r>
+            <a:r>
+              <a:rPr sz="1200" b="0">
+                <a:solidFill>
+                  <a:srgbClr val="282828"/>
+                </a:solidFill>
+                <a:latin typeface="Arial"/>
+              </a:rPr>
+              <a:t> 1.3 % at 0.2, 4.8 % at 0.5 — shrinkage.</a:t>
+            </a:r>
+          </a:p>
+          <a:p>
+            <a:pPr>
+              <a:spcAft>
+                <a:spcPts val="600"/>
+              </a:spcAft>
+            </a:pPr>
+            <a:r>
+              <a:rPr sz="1200" b="0">
+                <a:solidFill>
+                  <a:srgbClr val="282828"/>
+                </a:solidFill>
+                <a:latin typeface="Arial"/>
+              </a:rPr>
+              <a:t>•  </a:t>
+            </a:r>
+            <a:r>
+              <a:rPr sz="1200" b="1">
+                <a:solidFill>
+                  <a:srgbClr val="282828"/>
+                </a:solidFill>
+                <a:latin typeface="Arial"/>
+              </a:rPr>
+              <a:t>Iterated to convergence (the servo):</a:t>
+            </a:r>
+            <a:r>
+              <a:rPr sz="1200" b="0">
+                <a:solidFill>
+                  <a:srgbClr val="282828"/>
+                </a:solidFill>
+                <a:latin typeface="Arial"/>
+              </a:rPr>
+              <a:t> calibrated, the plain answer to 0.7 pitch then the same collapse; uncalibrated, the same to 0.5 pitch, 2.7 % at 0.6, divergent beyond — the loop's gain at the attenuated frequencies exceeds 2.</a:t>
+            </a:r>
+          </a:p>
+        </p:txBody>
+      </p:sp>
+      <p:sp>
+        <p:nvSpPr>
+          <p:cNvPr id="9" name="TextBox 8"/>
+          <p:cNvSpPr txBox="1"/>
+          <p:nvPr/>
+        </p:nvSpPr>
+        <p:spPr>
+          <a:xfrm>
+            <a:off x="6400800" y="6653784"/>
+            <a:ext cx="5394960" cy="274320"/>
+          </a:xfrm>
+          <a:prstGeom prst="rect">
+            <a:avLst/>
+          </a:prstGeom>
+          <a:noFill/>
+        </p:spPr>
+        <p:txBody>
+          <a:bodyPr wrap="square">
+            <a:spAutoFit/>
+          </a:bodyPr>
+          <a:lstStyle/>
+          <a:p>
+            <a:pPr>
+              <a:spcAft>
+                <a:spcPts val="600"/>
+              </a:spcAft>
+            </a:pPr>
+            <a:r>
+              <a:rPr sz="1050" b="0">
+                <a:solidFill>
+                  <a:srgbClr val="6E6E6E"/>
+                </a:solidFill>
+                <a:latin typeface="Arial"/>
+              </a:rPr>
+              <a:t>pupil_blur_demo_curve.png, top-left two panels; the three sweep tables in the report.</a:t>
+            </a:r>
+          </a:p>
+        </p:txBody>
+      </p:sp>
+    </p:spTree>
+  </p:cSld>
+  <p:clrMapOvr>
+    <a:masterClrMapping/>
+  </p:clrMapOvr>
+</p:sld>
+</file>
+
+<file path=ppt/slides/slide8.xml><?xml version="1.0" encoding="utf-8"?>
+<p:sld xmlns:a="http://schemas.openxmlformats.org/drawingml/2006/main" xmlns:p="http://schemas.openxmlformats.org/presentationml/2006/main" xmlns:r="http://schemas.openxmlformats.org/officeDocument/2006/relationships">
+  <p:cSld>
+    <p:spTree>
+      <p:nvGrpSpPr>
+        <p:cNvPr id="1" name=""/>
+        <p:cNvGrpSpPr/>
+        <p:nvPr/>
+      </p:nvGrpSpPr>
+      <p:grpSpPr/>
+      <p:sp>
+        <p:nvSpPr>
+          <p:cNvPr id="2" name="TextBox 1"/>
+          <p:cNvSpPr txBox="1"/>
+          <p:nvPr/>
+        </p:nvSpPr>
+        <p:spPr>
+          <a:xfrm>
+            <a:off x="411480" y="201168"/>
+            <a:ext cx="11368735" cy="914400"/>
+          </a:xfrm>
+          <a:prstGeom prst="rect">
+            <a:avLst/>
+          </a:prstGeom>
+          <a:noFill/>
+        </p:spPr>
+        <p:txBody>
+          <a:bodyPr wrap="square">
+            <a:spAutoFit/>
+          </a:bodyPr>
+          <a:lstStyle/>
+          <a:p>
+            <a:pPr>
+              <a:spcAft>
+                <a:spcPts val="400"/>
+              </a:spcAft>
+            </a:pPr>
+            <a:r>
+              <a:rPr sz="2400" b="1">
+                <a:solidFill>
+                  <a:srgbClr val="1F4E79"/>
+                </a:solidFill>
+                <a:latin typeface="Arial"/>
+              </a:rPr>
+              <a:t>Where the built benches sit</a:t>
+            </a:r>
+          </a:p>
+          <a:p>
+            <a:pPr>
+              <a:spcAft>
+                <a:spcPts val="0"/>
+              </a:spcAft>
+            </a:pPr>
+            <a:r>
+              <a:rPr sz="1250" b="0">
+                <a:solidFill>
+                  <a:srgbClr val="6E6E6E"/>
+                </a:solidFill>
+                <a:latin typeface="Arial"/>
+              </a:rPr>
+              <a:t>Both legs are at a hundredth of a pitch, where the uncalibrated cost is a few hundredths of a percent and the calibrated cost is unmeasurable — so the 0.13 / 0.29 % the gauge deck attributed to "blur" is mostly something else</a:t>
+            </a:r>
+          </a:p>
+        </p:txBody>
+      </p:sp>
+      <p:sp>
+        <p:nvSpPr>
+          <p:cNvPr id="3" name="Rectangle 2"/>
+          <p:cNvSpPr/>
+          <p:nvPr/>
+        </p:nvSpPr>
+        <p:spPr>
+          <a:xfrm>
+            <a:off x="411480" y="1133856"/>
+            <a:ext cx="11368735" cy="20320"/>
+          </a:xfrm>
+          <a:prstGeom prst="rect">
+            <a:avLst/>
+          </a:prstGeom>
+          <a:solidFill>
+            <a:srgbClr val="B8C6D4"/>
+          </a:solidFill>
+          <a:ln>
+            <a:noFill/>
+          </a:ln>
+          <a:effectLst/>
+        </p:spPr>
+        <p:style>
+          <a:lnRef idx="1">
+            <a:schemeClr val="accent1"/>
+          </a:lnRef>
+          <a:fillRef idx="3">
+            <a:schemeClr val="accent1"/>
+          </a:fillRef>
+          <a:effectRef idx="2">
+            <a:schemeClr val="accent1"/>
+          </a:effectRef>
+          <a:fontRef idx="minor">
+            <a:schemeClr val="lt1"/>
+          </a:fontRef>
+        </p:style>
+        <p:txBody>
+          <a:bodyPr rtlCol="0" anchor="ctr"/>
+          <a:lstStyle/>
+          <a:p>
+            <a:pPr algn="ctr"/>
+          </a:p>
+        </p:txBody>
+      </p:sp>
+      <p:pic>
+        <p:nvPicPr>
           <p:cNvPr id="4" name="Picture 3" descr="blur_crosscheck.png"/>
           <p:cNvPicPr>
             <a:picLocks noChangeAspect="1"/>
@@ -6901,7 +7600,7 @@
 </p:sld>
 </file>
 
-<file path=ppt/slides/slide7.xml><?xml version="1.0" encoding="utf-8"?>
+<file path=ppt/slides/slide9.xml><?xml version="1.0" encoding="utf-8"?>
 <p:sld xmlns:a="http://schemas.openxmlformats.org/drawingml/2006/main" xmlns:p="http://schemas.openxmlformats.org/presentationml/2006/main" xmlns:r="http://schemas.openxmlformats.org/officeDocument/2006/relationships">
   <p:cSld>
     <p:spTree>
@@ -7655,568 +8354,6 @@
 </p:sld>
 </file>
 
-<file path=ppt/slides/slide8.xml><?xml version="1.0" encoding="utf-8"?>
-<p:sld xmlns:a="http://schemas.openxmlformats.org/drawingml/2006/main" xmlns:p="http://schemas.openxmlformats.org/presentationml/2006/main" xmlns:r="http://schemas.openxmlformats.org/officeDocument/2006/relationships">
-  <p:cSld>
-    <p:spTree>
-      <p:nvGrpSpPr>
-        <p:cNvPr id="1" name=""/>
-        <p:cNvGrpSpPr/>
-        <p:nvPr/>
-      </p:nvGrpSpPr>
-      <p:grpSpPr/>
-      <p:sp>
-        <p:nvSpPr>
-          <p:cNvPr id="2" name="TextBox 1"/>
-          <p:cNvSpPr txBox="1"/>
-          <p:nvPr/>
-        </p:nvSpPr>
-        <p:spPr>
-          <a:xfrm>
-            <a:off x="411480" y="201168"/>
-            <a:ext cx="11368735" cy="914400"/>
-          </a:xfrm>
-          <a:prstGeom prst="rect">
-            <a:avLst/>
-          </a:prstGeom>
-          <a:noFill/>
-        </p:spPr>
-        <p:txBody>
-          <a:bodyPr wrap="square">
-            <a:spAutoFit/>
-          </a:bodyPr>
-          <a:lstStyle/>
-          <a:p>
-            <a:pPr>
-              <a:spcAft>
-                <a:spcPts val="400"/>
-              </a:spcAft>
-            </a:pPr>
-            <a:r>
-              <a:rPr sz="2400" b="1">
-                <a:solidFill>
-                  <a:srgbClr val="1F4E79"/>
-                </a:solidFill>
-                <a:latin typeface="Arial"/>
-              </a:rPr>
-              <a:t>What is approximate, and how to run it</a:t>
-            </a:r>
-          </a:p>
-          <a:p>
-            <a:pPr>
-              <a:spcAft>
-                <a:spcPts val="0"/>
-              </a:spcAft>
-            </a:pPr>
-            <a:r>
-              <a:rPr sz="1250" b="0">
-                <a:solidFill>
-                  <a:srgbClr val="6E6E6E"/>
-                </a:solidFill>
-                <a:latin typeface="Arial"/>
-              </a:rPr>
-              <a:t>The demo is a model of the blur alone; its three idealizations are stated, and every number is one command away</a:t>
-            </a:r>
-          </a:p>
-        </p:txBody>
-      </p:sp>
-      <p:sp>
-        <p:nvSpPr>
-          <p:cNvPr id="3" name="Rectangle 2"/>
-          <p:cNvSpPr/>
-          <p:nvPr/>
-        </p:nvSpPr>
-        <p:spPr>
-          <a:xfrm>
-            <a:off x="411480" y="1133856"/>
-            <a:ext cx="11368735" cy="20320"/>
-          </a:xfrm>
-          <a:prstGeom prst="rect">
-            <a:avLst/>
-          </a:prstGeom>
-          <a:solidFill>
-            <a:srgbClr val="B8C6D4"/>
-          </a:solidFill>
-          <a:ln>
-            <a:noFill/>
-          </a:ln>
-          <a:effectLst/>
-        </p:spPr>
-        <p:style>
-          <a:lnRef idx="1">
-            <a:schemeClr val="accent1"/>
-          </a:lnRef>
-          <a:fillRef idx="3">
-            <a:schemeClr val="accent1"/>
-          </a:fillRef>
-          <a:effectRef idx="2">
-            <a:schemeClr val="accent1"/>
-          </a:effectRef>
-          <a:fontRef idx="minor">
-            <a:schemeClr val="lt1"/>
-          </a:fontRef>
-        </p:style>
-        <p:txBody>
-          <a:bodyPr rtlCol="0" anchor="ctr"/>
-          <a:lstStyle/>
-          <a:p>
-            <a:pPr algn="ctr"/>
-          </a:p>
-        </p:txBody>
-      </p:sp>
-      <p:sp>
-        <p:nvSpPr>
-          <p:cNvPr id="4" name="TextBox 3"/>
-          <p:cNvSpPr txBox="1"/>
-          <p:nvPr/>
-        </p:nvSpPr>
-        <p:spPr>
-          <a:xfrm>
-            <a:off x="411480" y="1298448"/>
-            <a:ext cx="5806440" cy="274320"/>
-          </a:xfrm>
-          <a:prstGeom prst="rect">
-            <a:avLst/>
-          </a:prstGeom>
-          <a:noFill/>
-        </p:spPr>
-        <p:txBody>
-          <a:bodyPr wrap="square">
-            <a:spAutoFit/>
-          </a:bodyPr>
-          <a:lstStyle/>
-          <a:p>
-            <a:pPr>
-              <a:spcAft>
-                <a:spcPts val="600"/>
-              </a:spcAft>
-            </a:pPr>
-            <a:r>
-              <a:rPr sz="1200" b="0">
-                <a:solidFill>
-                  <a:srgbClr val="282828"/>
-                </a:solidFill>
-                <a:latin typeface="Arial"/>
-              </a:rPr>
-              <a:t>•  </a:t>
-            </a:r>
-            <a:r>
-              <a:rPr sz="1200" b="1">
-                <a:solidFill>
-                  <a:srgbClr val="282828"/>
-                </a:solidFill>
-                <a:latin typeface="Arial"/>
-              </a:rPr>
-              <a:t>The blur acts on the phase map.</a:t>
-            </a:r>
-            <a:r>
-              <a:rPr sz="1200" b="0">
-                <a:solidFill>
-                  <a:srgbClr val="282828"/>
-                </a:solidFill>
-                <a:latin typeface="Arial"/>
-              </a:rPr>
-              <a:t>  A camera blurs intensity; the four-step phase of blurred fringes equals the blurred phase only near null — true at 0.1 wave (the 30 nm surface), not at a wave.</a:t>
-            </a:r>
-          </a:p>
-          <a:p>
-            <a:pPr>
-              <a:spcAft>
-                <a:spcPts val="600"/>
-              </a:spcAft>
-            </a:pPr>
-            <a:r>
-              <a:rPr sz="1200" b="0">
-                <a:solidFill>
-                  <a:srgbClr val="282828"/>
-                </a:solidFill>
-                <a:latin typeface="Arial"/>
-              </a:rPr>
-              <a:t>•  </a:t>
-            </a:r>
-            <a:r>
-              <a:rPr sz="1200" b="1">
-                <a:solidFill>
-                  <a:srgbClr val="282828"/>
-                </a:solidFill>
-                <a:latin typeface="Arial"/>
-              </a:rPr>
-              <a:t>The built legs are not Gaussians.</a:t>
-            </a:r>
-            <a:r>
-              <a:rPr sz="1200" b="0">
-                <a:solidFill>
-                  <a:srgbClr val="282828"/>
-                </a:solidFill>
-                <a:latin typeface="Arial"/>
-              </a:rPr>
-              <a:t>  The rigorous tool finds a phase gain cos φ with amplitude cross-talk sin φ and a distortion; the Gaussian is matched to it at the actuator-Nyquist transfer only.</a:t>
-            </a:r>
-          </a:p>
-          <a:p>
-            <a:pPr>
-              <a:spcAft>
-                <a:spcPts val="600"/>
-              </a:spcAft>
-            </a:pPr>
-            <a:r>
-              <a:rPr sz="1200" b="0">
-                <a:solidFill>
-                  <a:srgbClr val="282828"/>
-                </a:solidFill>
-                <a:latin typeface="Arial"/>
-              </a:rPr>
-              <a:t>•  </a:t>
-            </a:r>
-            <a:r>
-              <a:rPr sz="1200" b="1">
-                <a:solidFill>
-                  <a:srgbClr val="282828"/>
-                </a:solidFill>
-                <a:latin typeface="Arial"/>
-              </a:rPr>
-              <a:t>The lit set</a:t>
-            </a:r>
-            <a:r>
-              <a:rPr sz="1200" b="0">
-                <a:solidFill>
-                  <a:srgbClr val="282828"/>
-                </a:solidFill>
-                <a:latin typeface="Arial"/>
-              </a:rPr>
-              <a:t> is the demo's 2852 actuators (0.85 × 0.74 of the aperture radius); the benches light 5072 (lens) and 6948 (mirror) from the traced cone.  The error is a per-actuator rms, so the count sets the edge-to-interior ratio, not the scale.</a:t>
-            </a:r>
-          </a:p>
-        </p:txBody>
-      </p:sp>
-      <p:sp>
-        <p:nvSpPr>
-          <p:cNvPr id="5" name="Rectangle 4"/>
-          <p:cNvSpPr/>
-          <p:nvPr/>
-        </p:nvSpPr>
-        <p:spPr>
-          <a:xfrm>
-            <a:off x="6400800" y="1298448"/>
-            <a:ext cx="5394960" cy="1009154"/>
-          </a:xfrm>
-          <a:prstGeom prst="rect">
-            <a:avLst/>
-          </a:prstGeom>
-          <a:solidFill>
-            <a:srgbClr val="FFFFFF"/>
-          </a:solidFill>
-          <a:ln w="9525">
-            <a:solidFill>
-              <a:srgbClr val="1F4E79"/>
-            </a:solidFill>
-          </a:ln>
-          <a:effectLst/>
-        </p:spPr>
-        <p:style>
-          <a:lnRef idx="1">
-            <a:schemeClr val="accent1"/>
-          </a:lnRef>
-          <a:fillRef idx="3">
-            <a:schemeClr val="accent1"/>
-          </a:fillRef>
-          <a:effectRef idx="2">
-            <a:schemeClr val="accent1"/>
-          </a:effectRef>
-          <a:fontRef idx="minor">
-            <a:schemeClr val="lt1"/>
-          </a:fontRef>
-        </p:style>
-        <p:txBody>
-          <a:bodyPr rtlCol="0" anchor="t" wrap="square"/>
-          <a:lstStyle/>
-          <a:p>
-            <a:pPr algn="l">
-              <a:spcAft>
-                <a:spcPts val="100"/>
-              </a:spcAft>
-            </a:pPr>
-            <a:r>
-              <a:rPr sz="1007" b="0">
-                <a:solidFill>
-                  <a:srgbClr val="282828"/>
-                </a:solidFill>
-                <a:latin typeface="Consolas"/>
-              </a:rPr>
-              <a:t>cd &lt;path&gt;/mmacos/templates/40_benches/tg_psi_dm96_oap</a:t>
-            </a:r>
-          </a:p>
-          <a:p>
-            <a:pPr algn="l">
-              <a:spcAft>
-                <a:spcPts val="100"/>
-              </a:spcAft>
-            </a:pPr>
-            <a:r>
-              <a:rPr sz="1007" b="0">
-                <a:solidFill>
-                  <a:srgbClr val="282828"/>
-                </a:solidFill>
-                <a:latin typeface="Consolas"/>
-              </a:rPr>
-              <a:t>matlab</a:t>
-            </a:r>
-          </a:p>
-          <a:p>
-            <a:pPr algn="l">
-              <a:spcAft>
-                <a:spcPts val="100"/>
-              </a:spcAft>
-            </a:pPr>
-            <a:r>
-              <a:rPr sz="1007" b="0">
-                <a:solidFill>
-                  <a:srgbClr val="282828"/>
-                </a:solidFill>
-                <a:latin typeface="Consolas"/>
-              </a:rPr>
-              <a:t>&gt;&gt; pupil_blur_demo                    % ~1 min, no engine</a:t>
-            </a:r>
-          </a:p>
-          <a:p>
-            <a:pPr algn="l">
-              <a:spcAft>
-                <a:spcPts val="100"/>
-              </a:spcAft>
-            </a:pPr>
-            <a:r>
-              <a:rPr sz="1007" b="0">
-                <a:solidFill>
-                  <a:srgbClr val="282828"/>
-                </a:solidFill>
-                <a:latin typeface="Consolas"/>
-              </a:rPr>
-              <a:t>&gt;&gt; pupil_blur_demo('steps_sig', 0.8)  % the steps at another blur</a:t>
-            </a:r>
-          </a:p>
-          <a:p>
-            <a:pPr algn="l">
-              <a:spcAft>
-                <a:spcPts val="100"/>
-              </a:spcAft>
-            </a:pPr>
-            <a:r>
-              <a:rPr sz="1007" b="0">
-                <a:solidFill>
-                  <a:srgbClr val="282828"/>
-                </a:solidFill>
-                <a:latin typeface="Consolas"/>
-              </a:rPr>
-              <a:t>&gt;&gt; pupil_blur_lam_m                   % the weight vs noise (backup)</a:t>
-            </a:r>
-          </a:p>
-        </p:txBody>
-      </p:sp>
-      <p:sp>
-        <p:nvSpPr>
-          <p:cNvPr id="6" name="TextBox 5"/>
-          <p:cNvSpPr txBox="1"/>
-          <p:nvPr/>
-        </p:nvSpPr>
-        <p:spPr>
-          <a:xfrm>
-            <a:off x="6400800" y="2417330"/>
-            <a:ext cx="5394960" cy="274320"/>
-          </a:xfrm>
-          <a:prstGeom prst="rect">
-            <a:avLst/>
-          </a:prstGeom>
-          <a:noFill/>
-        </p:spPr>
-        <p:txBody>
-          <a:bodyPr wrap="square">
-            <a:spAutoFit/>
-          </a:bodyPr>
-          <a:lstStyle/>
-          <a:p>
-            <a:pPr>
-              <a:spcAft>
-                <a:spcPts val="600"/>
-              </a:spcAft>
-            </a:pPr>
-            <a:r>
-              <a:rPr sz="1200" b="0">
-                <a:solidFill>
-                  <a:srgbClr val="282828"/>
-                </a:solidFill>
-                <a:latin typeface="Arial"/>
-              </a:rPr>
-              <a:t>•  </a:t>
-            </a:r>
-            <a:r>
-              <a:rPr sz="1200" b="1">
-                <a:solidFill>
-                  <a:srgbClr val="282828"/>
-                </a:solidFill>
-                <a:latin typeface="Arial"/>
-              </a:rPr>
-              <a:t>Test:</a:t>
-            </a:r>
-            <a:r>
-              <a:rPr sz="1200" b="0">
-                <a:solidFill>
-                  <a:srgbClr val="282828"/>
-                </a:solidFill>
-                <a:latin typeface="Arial"/>
-              </a:rPr>
-              <a:t> ./run_mmacos_tests.sh tPupilBlurDemo (5 assertions, ~7 s; the all-unknowns solve kept as the must-fail control).</a:t>
-            </a:r>
-          </a:p>
-        </p:txBody>
-      </p:sp>
-      <p:sp>
-        <p:nvSpPr>
-          <p:cNvPr id="7" name="TextBox 6"/>
-          <p:cNvSpPr txBox="1"/>
-          <p:nvPr/>
-        </p:nvSpPr>
-        <p:spPr>
-          <a:xfrm>
-            <a:off x="6400800" y="2990354"/>
-            <a:ext cx="5394960" cy="274320"/>
-          </a:xfrm>
-          <a:prstGeom prst="rect">
-            <a:avLst/>
-          </a:prstGeom>
-          <a:noFill/>
-        </p:spPr>
-        <p:txBody>
-          <a:bodyPr wrap="square">
-            <a:spAutoFit/>
-          </a:bodyPr>
-          <a:lstStyle/>
-          <a:p>
-            <a:pPr>
-              <a:spcAft>
-                <a:spcPts val="600"/>
-              </a:spcAft>
-            </a:pPr>
-            <a:r>
-              <a:rPr sz="1050" b="0">
-                <a:solidFill>
-                  <a:srgbClr val="6E6E6E"/>
-                </a:solidFill>
-                <a:latin typeface="Arial"/>
-              </a:rPr>
-              <a:t>Public: nasa-jpl/MACOS_resources, branch dev-candidate.</a:t>
-            </a:r>
-          </a:p>
-        </p:txBody>
-      </p:sp>
-    </p:spTree>
-  </p:cSld>
-  <p:clrMapOvr>
-    <a:masterClrMapping/>
-  </p:clrMapOvr>
-</p:sld>
-</file>
-
-<file path=ppt/slides/slide9.xml><?xml version="1.0" encoding="utf-8"?>
-<p:sld xmlns:a="http://schemas.openxmlformats.org/drawingml/2006/main" xmlns:p="http://schemas.openxmlformats.org/presentationml/2006/main" xmlns:r="http://schemas.openxmlformats.org/officeDocument/2006/relationships">
-  <p:cSld>
-    <p:spTree>
-      <p:nvGrpSpPr>
-        <p:cNvPr id="1" name=""/>
-        <p:cNvGrpSpPr/>
-        <p:nvPr/>
-      </p:nvGrpSpPr>
-      <p:grpSpPr/>
-      <p:sp>
-        <p:nvSpPr>
-          <p:cNvPr id="2" name="TextBox 1"/>
-          <p:cNvSpPr txBox="1"/>
-          <p:nvPr/>
-        </p:nvSpPr>
-        <p:spPr>
-          <a:xfrm>
-            <a:off x="411480" y="201168"/>
-            <a:ext cx="11368735" cy="914400"/>
-          </a:xfrm>
-          <a:prstGeom prst="rect">
-            <a:avLst/>
-          </a:prstGeom>
-          <a:noFill/>
-        </p:spPr>
-        <p:txBody>
-          <a:bodyPr wrap="square">
-            <a:spAutoFit/>
-          </a:bodyPr>
-          <a:lstStyle/>
-          <a:p>
-            <a:pPr>
-              <a:spcAft>
-                <a:spcPts val="400"/>
-              </a:spcAft>
-            </a:pPr>
-            <a:r>
-              <a:rPr sz="2400" b="1">
-                <a:solidFill>
-                  <a:srgbClr val="1F4E79"/>
-                </a:solidFill>
-                <a:latin typeface="Arial"/>
-              </a:rPr>
-              <a:t>Backup</a:t>
-            </a:r>
-          </a:p>
-        </p:txBody>
-      </p:sp>
-      <p:sp>
-        <p:nvSpPr>
-          <p:cNvPr id="3" name="Rectangle 2"/>
-          <p:cNvSpPr/>
-          <p:nvPr/>
-        </p:nvSpPr>
-        <p:spPr>
-          <a:xfrm>
-            <a:off x="411480" y="914400"/>
-            <a:ext cx="11368735" cy="20320"/>
-          </a:xfrm>
-          <a:prstGeom prst="rect">
-            <a:avLst/>
-          </a:prstGeom>
-          <a:solidFill>
-            <a:srgbClr val="B8C6D4"/>
-          </a:solidFill>
-          <a:ln>
-            <a:noFill/>
-          </a:ln>
-          <a:effectLst/>
-        </p:spPr>
-        <p:style>
-          <a:lnRef idx="1">
-            <a:schemeClr val="accent1"/>
-          </a:lnRef>
-          <a:fillRef idx="3">
-            <a:schemeClr val="accent1"/>
-          </a:fillRef>
-          <a:effectRef idx="2">
-            <a:schemeClr val="accent1"/>
-          </a:effectRef>
-          <a:fontRef idx="minor">
-            <a:schemeClr val="lt1"/>
-          </a:fontRef>
-        </p:style>
-        <p:txBody>
-          <a:bodyPr rtlCol="0" anchor="ctr"/>
-          <a:lstStyle/>
-          <a:p>
-            <a:pPr algn="ctr"/>
-          </a:p>
-        </p:txBody>
-      </p:sp>
-    </p:spTree>
-  </p:cSld>
-  <p:clrMapOvr>
-    <a:masterClrMapping/>
-  </p:clrMapOvr>
-</p:sld>
-</file>
-
 <file path=ppt/theme/theme1.xml><?xml version="1.0" encoding="utf-8"?>
 <a:theme xmlns:a="http://schemas.openxmlformats.org/drawingml/2006/main" name="Office Theme">
   <a:themeElements>

</xml_diff>

<commit_message>
deck_blur: Dave's edit-copy pass folded -- slide 2 sub-bullets (the reconstruction without / with calibration; the two reconstructors and their two uses) as indented sub-bullets, 'The DM surface gauge performance' head; edit copy synced
Co-Authored-By: Claude Fable 5.1 <noreply@anthropic.com>
</commit_message>
<xml_diff>
--- a/demo_session/deck_blur.pptx
+++ b/demo_session/deck_blur.pptx
@@ -5495,43 +5495,75 @@
                 </a:solidFill>
                 <a:latin typeface="Arial"/>
               </a:rPr>
-              <a:t>  The actuator commands are recovered from the blurred map by least squares against a response matrix (one column per lit actuator), </a:t>
-            </a:r>
-            <a:r>
-              <a:rPr sz="1200" b="1">
-                <a:solidFill>
-                  <a:srgbClr val="282828"/>
+              <a:t>  The actuator commands are recovered from the blurred map by least squares against a response matrix (one column per lit actuator)</a:t>
+            </a:r>
+          </a:p>
+          <a:p>
+            <a:pPr marL="594360" indent="-137160">
+              <a:spcAft>
+                <a:spcPts val="500"/>
+              </a:spcAft>
+            </a:pPr>
+            <a:r>
+              <a:rPr sz="1050" b="0">
+                <a:solidFill>
+                  <a:srgbClr val="6E6E6E"/>
+                </a:solidFill>
+                <a:latin typeface="Arial"/>
+              </a:rPr>
+              <a:t>–  </a:t>
+            </a:r>
+            <a:r>
+              <a:rPr sz="1050" b="1">
+                <a:solidFill>
+                  <a:srgbClr val="6E6E6E"/>
                 </a:solidFill>
                 <a:latin typeface="Arial"/>
               </a:rPr>
               <a:t>without calibration</a:t>
             </a:r>
             <a:r>
-              <a:rPr sz="1200" b="0">
-                <a:solidFill>
-                  <a:srgbClr val="282828"/>
-                </a:solidFill>
-                <a:latin typeface="Arial"/>
-              </a:rPr>
-              <a:t> — the matrix built from the unblurred influence, as if no one knew about the blur — and </a:t>
-            </a:r>
-            <a:r>
-              <a:rPr sz="1200" b="1">
-                <a:solidFill>
-                  <a:srgbClr val="282828"/>
+              <a:rPr sz="1050" b="0">
+                <a:solidFill>
+                  <a:srgbClr val="6E6E6E"/>
+                </a:solidFill>
+                <a:latin typeface="Arial"/>
+              </a:rPr>
+              <a:t> — the matrix built from the unblurred influence, as if no one knew about the blur</a:t>
+            </a:r>
+          </a:p>
+          <a:p>
+            <a:pPr marL="594360" indent="-137160">
+              <a:spcAft>
+                <a:spcPts val="500"/>
+              </a:spcAft>
+            </a:pPr>
+            <a:r>
+              <a:rPr sz="1050" b="0">
+                <a:solidFill>
+                  <a:srgbClr val="6E6E6E"/>
+                </a:solidFill>
+                <a:latin typeface="Arial"/>
+              </a:rPr>
+              <a:t>–  </a:t>
+            </a:r>
+            <a:r>
+              <a:rPr sz="1050" b="1">
+                <a:solidFill>
+                  <a:srgbClr val="6E6E6E"/>
                 </a:solidFill>
                 <a:latin typeface="Arial"/>
               </a:rPr>
               <a:t>with calibration</a:t>
             </a:r>
             <a:r>
-              <a:rPr sz="1200" b="0">
-                <a:solidFill>
-                  <a:srgbClr val="282828"/>
-                </a:solidFill>
-                <a:latin typeface="Arial"/>
-              </a:rPr>
-              <a:t> — the matrix built from the blurred influence, which is what measuring the response matrix through the camera does automatically.</a:t>
+              <a:rPr sz="1050" b="0">
+                <a:solidFill>
+                  <a:srgbClr val="6E6E6E"/>
+                </a:solidFill>
+                <a:latin typeface="Arial"/>
+              </a:rPr>
+              <a:t> — the matrix built from the blurred influence, which is what measuring the response matrix through the camera does automatically</a:t>
             </a:r>
           </a:p>
           <a:p>
@@ -5615,46 +5647,85 @@
               </a:rPr>
               <a:t>Two reconstructors, and two ways to use them.</a:t>
             </a:r>
-            <a:r>
-              <a:rPr sz="1200" b="0">
-                <a:solidFill>
-                  <a:srgbClr val="282828"/>
-                </a:solidFill>
-                <a:latin typeface="Arial"/>
-              </a:rPr>
-              <a:t>  Plain least squares: the matrix inverted with no regularization to speak of (λ = 10⁻⁹) — the simplest estimator, and the indicator of where any estimator converges.  The gauge's own: the same matrix with the record's Tikhonov weight (λ_m = 10⁻³ of the median column energy), which protects the measured matrix against its own noise at the price of shrinking a single estimate (1 % on this surface at zero blur).  Each is shown </a:t>
-            </a:r>
-            <a:r>
-              <a:rPr sz="1200" b="1">
-                <a:solidFill>
-                  <a:srgbClr val="282828"/>
+          </a:p>
+          <a:p>
+            <a:pPr marL="594360" indent="-137160">
+              <a:spcAft>
+                <a:spcPts val="500"/>
+              </a:spcAft>
+            </a:pPr>
+            <a:r>
+              <a:rPr sz="1050" b="0">
+                <a:solidFill>
+                  <a:srgbClr val="6E6E6E"/>
+                </a:solidFill>
+                <a:latin typeface="Arial"/>
+              </a:rPr>
+              <a:t>–  Plain least squares: the matrix inverted with no regularization to speak of (λ = 10⁻⁹) — the simplest estimator, and the indicator of where any estimator converges.</a:t>
+            </a:r>
+          </a:p>
+          <a:p>
+            <a:pPr marL="594360" indent="-137160">
+              <a:spcAft>
+                <a:spcPts val="500"/>
+              </a:spcAft>
+            </a:pPr>
+            <a:r>
+              <a:rPr sz="1050" b="0">
+                <a:solidFill>
+                  <a:srgbClr val="6E6E6E"/>
+                </a:solidFill>
+                <a:latin typeface="Arial"/>
+              </a:rPr>
+              <a:t>–  The gauge's own: the same matrix with the record's Tikhonov weight (λ_m = 10⁻³ of the median column energy), which protects the measured matrix against its own noise at the price of shrinking a single estimate (1 % on this surface at zero blur).</a:t>
+            </a:r>
+          </a:p>
+          <a:p>
+            <a:pPr marL="594360" indent="-137160">
+              <a:spcAft>
+                <a:spcPts val="500"/>
+              </a:spcAft>
+            </a:pPr>
+            <a:r>
+              <a:rPr sz="1050" b="0">
+                <a:solidFill>
+                  <a:srgbClr val="6E6E6E"/>
+                </a:solidFill>
+                <a:latin typeface="Arial"/>
+              </a:rPr>
+              <a:t>–  Each is shown </a:t>
+            </a:r>
+            <a:r>
+              <a:rPr sz="1050" b="1">
+                <a:solidFill>
+                  <a:srgbClr val="6E6E6E"/>
                 </a:solidFill>
                 <a:latin typeface="Arial"/>
               </a:rPr>
               <a:t>one shot</a:t>
             </a:r>
             <a:r>
-              <a:rPr sz="1200" b="0">
-                <a:solidFill>
-                  <a:srgbClr val="282828"/>
+              <a:rPr sz="1050" b="0">
+                <a:solidFill>
+                  <a:srgbClr val="6E6E6E"/>
                 </a:solidFill>
                 <a:latin typeface="Arial"/>
               </a:rPr>
               <a:t> (a capture, an absolute read) and </a:t>
             </a:r>
             <a:r>
-              <a:rPr sz="1200" b="1">
-                <a:solidFill>
-                  <a:srgbClr val="282828"/>
+              <a:rPr sz="1050" b="1">
+                <a:solidFill>
+                  <a:srgbClr val="6E6E6E"/>
                 </a:solidFill>
                 <a:latin typeface="Arial"/>
               </a:rPr>
               <a:t>driven to convergence</a:t>
             </a:r>
             <a:r>
-              <a:rPr sz="1200" b="0">
-                <a:solidFill>
-                  <a:srgbClr val="282828"/>
+              <a:rPr sz="1050" b="0">
+                <a:solidFill>
+                  <a:srgbClr val="6E6E6E"/>
                 </a:solidFill>
                 <a:latin typeface="Arial"/>
               </a:rPr>
@@ -5683,7 +5754,7 @@
                 </a:solidFill>
                 <a:latin typeface="Arial"/>
               </a:rPr>
-              <a:t>The built benches on the axis.</a:t>
+              <a:t>The DM surface gauge performance.</a:t>
             </a:r>
             <a:r>
               <a:rPr sz="1200" b="0">
@@ -5705,7 +5776,7 @@
         </p:nvSpPr>
         <p:spPr>
           <a:xfrm>
-            <a:off x="6400800" y="4389120"/>
+            <a:off x="6400800" y="4920234"/>
             <a:ext cx="5394960" cy="274320"/>
           </a:xfrm>
           <a:prstGeom prst="rect">

</xml_diff>